<commit_message>
Align with Laboratory Work Report Template, remove alternative method, add technical problem evidence and screenshots
</commit_message>
<xml_diff>
--- a/docs/Midterm_Presentation_Team2.pptx
+++ b/docs/Midterm_Presentation_Team2.pptx
@@ -3201,7 +3201,7 @@
               </a:defRPr>
             </a:pPr>
             <a:r>
-              <a:t>Primary: GraphCodeBERT + Data Flow Classifier | Alternative: Frozen Embeddings + Random Forest</a:t>
+              <a:t>GraphCodeBERT + Data Flow Classifier (Semantic &amp; Def-Use Analysis)</a:t>
             </a:r>
           </a:p>
           <a:p>
@@ -3231,7 +3231,7 @@
               </a:defRPr>
             </a:pPr>
             <a:r>
-              <a:t>Course: Management of Organizational Data (MoOD) | Repository: https://github.com/Tasik1/kbtu-mood-midterm-team2</a:t>
+              <a:t>Course: MSITM 5134 Management of Organizational Data | Instructor: Nazgul T. Seralina | GitHub: Tasik1/kbtu-mood-midterm-team2</a:t>
             </a:r>
           </a:p>
         </p:txBody>
@@ -3520,7 +3520,7 @@
               </a:defRPr>
             </a:pPr>
             <a:r>
-              <a:t>• Production orchestrator script &amp; dependency management</a:t>
+              <a:t>• Network proxy engineering for restricted environment bypass</a:t>
             </a:r>
           </a:p>
         </p:txBody>
@@ -3741,7 +3741,7 @@
               </a:defRPr>
             </a:pPr>
             <a:r>
-              <a:t>• End-to-end primary classifier head training &amp; tuning</a:t>
+              <a:t>• Model architecture optimization &amp; memory profiling</a:t>
             </a:r>
           </a:p>
         </p:txBody>
@@ -3962,7 +3962,7 @@
               </a:defRPr>
             </a:pPr>
             <a:r>
-              <a:t>• CWE taxonomy mapping and class imbalance assessment</a:t>
+              <a:t>• CWE taxonomy mapping and class balance assessment</a:t>
             </a:r>
           </a:p>
         </p:txBody>
@@ -4099,7 +4099,7 @@
               </a:defRPr>
             </a:pPr>
             <a:r>
-              <a:t>25MD0304 • Evaluation &amp; Baseline Analyst</a:t>
+              <a:t>25MD0304 • Evaluation Analyst</a:t>
             </a:r>
           </a:p>
         </p:txBody>
@@ -4138,7 +4138,7 @@
               </a:defRPr>
             </a:pPr>
             <a:r>
-              <a:t>• Alternative model (Frozen Embeddings + Random Forest) design</a:t>
+              <a:t>• Holdout test evaluation (Accuracy &gt;= 93%, F1, ROC-AUC)</a:t>
             </a:r>
           </a:p>
           <a:p>
@@ -4153,7 +4153,7 @@
               </a:defRPr>
             </a:pPr>
             <a:r>
-              <a:t>• Holdout test evaluation (Accuracy &gt;= 93%, F1, ROC-AUC)</a:t>
+              <a:t>• Diagnostic analysis of False Positives &amp; False Negatives</a:t>
             </a:r>
           </a:p>
           <a:p>
@@ -4168,7 +4168,7 @@
               </a:defRPr>
             </a:pPr>
             <a:r>
-              <a:t>• Confusion matrix &amp; error case diagnostic analysis</a:t>
+              <a:t>• Publication-quality visualization generation &amp; terminal logging</a:t>
             </a:r>
           </a:p>
           <a:p>
@@ -4183,7 +4183,7 @@
               </a:defRPr>
             </a:pPr>
             <a:r>
-              <a:t>• Technical report &amp; slide deck compilation for live defense</a:t>
+              <a:t>• Technical report &amp; slide deck compilation for defense</a:t>
             </a:r>
           </a:p>
         </p:txBody>
@@ -4305,7 +4305,7 @@
               </a:defRPr>
             </a:pPr>
             <a:r>
-              <a:t>Traditional Static Application Security Testing (SAST) tools rely on rigid AST pattern matching, resulting in overwhelming false-positive rates (&gt;60%) and an inability to understand non-local data-flow semantics.</a:t>
+              <a:t>Traditional Static Application Security Testing (SAST) tools rely on rigid lexical pattern matching and surface AST rules, producing false-positive rates &gt;60% and missing non-local taint flows across complex methods.</a:t>
             </a:r>
           </a:p>
           <a:p>
@@ -4335,7 +4335,7 @@
               </a:defRPr>
             </a:pPr>
             <a:r>
-              <a:t>Vulnerability datasets from historical git commits represent critical organizational assets. Effective data management transforms raw source code into high-fidelity training corpuses that power automated DevSecOps decisions.</a:t>
+              <a:t>Source code repositories, commit histories, and security logs represent enterprise data assets. Disciplined data management transforms raw commit diffs into high-fidelity training corpuses that power automated DevSecOps decisions.</a:t>
             </a:r>
           </a:p>
           <a:p>
@@ -4350,7 +4350,7 @@
               </a:defRPr>
             </a:pPr>
             <a:r>
-              <a:t>▶  Why GraphCodeBERT?</a:t>
+              <a:t>▶  Why GraphCodeBERT + Data Flow?</a:t>
             </a:r>
           </a:p>
           <a:p>
@@ -4365,7 +4365,7 @@
               </a:defRPr>
             </a:pPr>
             <a:r>
-              <a:t>Standard LLMs (like CodeBERT or RoBERTa) treat code purely as a flat lexical sequence. GraphCodeBERT integrates data-flow graphs (variable def-use chains), enabling neural attention to follow taint propagation across methods.</a:t>
+              <a:t>Standard LLMs treat code purely as flat text. GraphCodeBERT integrates data-flow graphs (variable def-use chains), enabling neural attention to follow taint propagation across methods.</a:t>
             </a:r>
           </a:p>
           <a:p>
@@ -4380,7 +4380,7 @@
               </a:defRPr>
             </a:pPr>
             <a:r>
-              <a:t>▶  Primary vs. Alternative Mandate</a:t>
+              <a:t>▶  Syllabus Target Requirement</a:t>
             </a:r>
           </a:p>
           <a:p>
@@ -4395,7 +4395,7 @@
               </a:defRPr>
             </a:pPr>
             <a:r>
-              <a:t>Master students must evaluate technological trade-offs: full transformer graph attention (Primary) vs. frozen embeddings with lightweight ensemble trees (Alternative) based on enterprise compute budgets.</a:t>
+              <a:t>Master students must demonstrate data governance, quality engineering, and deep learning modeling to achieve an enterprise acceptance threshold of Accuracy &gt;= 93% on strict holdout test data.</a:t>
             </a:r>
           </a:p>
         </p:txBody>
@@ -5057,7 +5057,7 @@
             </a:r>
             <a:br/>
             <a:r>
-              <a:t>+ ROC-AUC &amp; Confusion Mtx</a:t>
+              <a:t>(Achieved: 94.44%)</a:t>
             </a:r>
           </a:p>
         </p:txBody>
@@ -5636,7 +5636,7 @@
               </a:defRPr>
             </a:pPr>
             <a:r>
-              <a:t>▶  DFG Extractor Implementation (midterm/models/data_flow_extractor.py)</a:t>
+              <a:t>▶  DFG Extractor Implementation (models/data_flow_extractor.py)</a:t>
             </a:r>
           </a:p>
           <a:p>
@@ -5666,7 +5666,7 @@
               </a:defRPr>
             </a:pPr>
             <a:r>
-              <a:t>▶  Why Data Flow Detects Vulnerabilities</a:t>
+              <a:t>▶  Adjacency-Guided Attention Masking</a:t>
             </a:r>
           </a:p>
           <a:p>
@@ -5681,7 +5681,7 @@
               </a:defRPr>
             </a:pPr>
             <a:r>
-              <a:t>Vulnerabilities such as SQL injection (CWE-89), XSS (CWE-79), and Path Traversal (CWE-22) are fundamentally data-flow flaws: tainted untrusted input reaches an execution sink without intermediate sanitization.</a:t>
+              <a:t>Multi-head graph attention restricts attention weights to connected variable pairs in matrix A, allowing the model to focus specifically on semantic data flow trajectories.</a:t>
             </a:r>
           </a:p>
         </p:txBody>
@@ -5734,7 +5734,7 @@
               </a:defRPr>
             </a:pPr>
             <a:r>
-              <a:t>AI MODELING — TEAM 2</a:t>
+              <a:t>ENGINEERING RIGOR &amp; PROBLEM SOLVING</a:t>
             </a:r>
           </a:p>
           <a:p>
@@ -5749,111 +5749,21 @@
               </a:defRPr>
             </a:pPr>
             <a:r>
-              <a:t>Primary vs. Alternative Model Architecture</a:t>
-            </a:r>
-          </a:p>
-        </p:txBody>
-      </p:sp>
-      <p:sp>
-        <p:nvSpPr>
-          <p:cNvPr id="3" name="Rounded Rectangle 2"/>
-          <p:cNvSpPr/>
+              <a:t>Technical Obstacles Encountered &amp; Debugging Evidence</a:t>
+            </a:r>
+          </a:p>
+        </p:txBody>
+      </p:sp>
+      <p:sp>
+        <p:nvSpPr>
+          <p:cNvPr id="3" name="TextBox 2"/>
+          <p:cNvSpPr txBox="1"/>
           <p:nvPr/>
         </p:nvSpPr>
         <p:spPr>
           <a:xfrm>
             <a:off x="731520" y="1645920"/>
             <a:ext cx="5120640" cy="4572000"/>
-          </a:xfrm>
-          <a:prstGeom prst="roundRect">
-            <a:avLst/>
-          </a:prstGeom>
-          <a:solidFill>
-            <a:srgbClr val="FFFFFF"/>
-          </a:solidFill>
-          <a:ln>
-            <a:solidFill>
-              <a:srgbClr val="1B365D"/>
-            </a:solidFill>
-          </a:ln>
-        </p:spPr>
-        <p:style>
-          <a:lnRef idx="1">
-            <a:schemeClr val="accent1"/>
-          </a:lnRef>
-          <a:fillRef idx="3">
-            <a:schemeClr val="accent1"/>
-          </a:fillRef>
-          <a:effectRef idx="2">
-            <a:schemeClr val="accent1"/>
-          </a:effectRef>
-          <a:fontRef idx="minor">
-            <a:schemeClr val="lt1"/>
-          </a:fontRef>
-        </p:style>
-        <p:txBody>
-          <a:bodyPr rtlCol="0" anchor="ctr"/>
-          <a:lstStyle/>
-          <a:p>
-            <a:pPr algn="ctr"/>
-          </a:p>
-        </p:txBody>
-      </p:sp>
-      <p:sp>
-        <p:nvSpPr>
-          <p:cNvPr id="4" name="Rectangle 3"/>
-          <p:cNvSpPr/>
-          <p:nvPr/>
-        </p:nvSpPr>
-        <p:spPr>
-          <a:xfrm>
-            <a:off x="731520" y="1645920"/>
-            <a:ext cx="5120640" cy="822960"/>
-          </a:xfrm>
-          <a:prstGeom prst="rect">
-            <a:avLst/>
-          </a:prstGeom>
-          <a:solidFill>
-            <a:srgbClr val="1B365D"/>
-          </a:solidFill>
-          <a:ln>
-            <a:solidFill>
-              <a:srgbClr val="1B365D"/>
-            </a:solidFill>
-          </a:ln>
-        </p:spPr>
-        <p:style>
-          <a:lnRef idx="1">
-            <a:schemeClr val="accent1"/>
-          </a:lnRef>
-          <a:fillRef idx="3">
-            <a:schemeClr val="accent1"/>
-          </a:fillRef>
-          <a:effectRef idx="2">
-            <a:schemeClr val="accent1"/>
-          </a:effectRef>
-          <a:fontRef idx="minor">
-            <a:schemeClr val="lt1"/>
-          </a:fontRef>
-        </p:style>
-        <p:txBody>
-          <a:bodyPr rtlCol="0" anchor="ctr"/>
-          <a:lstStyle/>
-          <a:p>
-            <a:pPr algn="ctr"/>
-          </a:p>
-        </p:txBody>
-      </p:sp>
-      <p:sp>
-        <p:nvSpPr>
-          <p:cNvPr id="5" name="TextBox 4"/>
-          <p:cNvSpPr txBox="1"/>
-          <p:nvPr/>
-        </p:nvSpPr>
-        <p:spPr>
-          <a:xfrm>
-            <a:off x="822960" y="1691640"/>
-            <a:ext cx="4937760" cy="731520"/>
           </a:xfrm>
           <a:prstGeom prst="rect">
             <a:avLst/>
@@ -5861,34 +5771,109 @@
           <a:noFill/>
         </p:spPr>
         <p:txBody>
-          <a:bodyPr wrap="none">
+          <a:bodyPr wrap="square">
             <a:spAutoFit/>
           </a:bodyPr>
           <a:lstStyle/>
           <a:p>
             <a:pPr>
-              <a:defRPr sz="1200" b="1">
-                <a:solidFill>
-                  <a:srgbClr val="FFFFFF"/>
-                </a:solidFill>
-              </a:defRPr>
-            </a:pPr>
-            <a:r>
-              <a:t>PRIMARY METHOD: GraphCodeBERT + DFG Classifier</a:t>
-            </a:r>
-          </a:p>
-        </p:txBody>
-      </p:sp>
-      <p:sp>
-        <p:nvSpPr>
-          <p:cNvPr id="6" name="TextBox 5"/>
+              <a:defRPr sz="1300" b="1">
+                <a:solidFill>
+                  <a:srgbClr val="C53030"/>
+                </a:solidFill>
+              </a:defRPr>
+            </a:pPr>
+            <a:r>
+              <a:t>Problem 1: Campus Network Port 443 Blocking</a:t>
+            </a:r>
+          </a:p>
+          <a:p>
+            <a:pPr>
+              <a:spcBef>
+                <a:spcPts val="600"/>
+              </a:spcBef>
+              <a:defRPr sz="1050">
+                <a:solidFill>
+                  <a:srgbClr val="1A202C"/>
+                </a:solidFill>
+              </a:defRPr>
+            </a:pPr>
+            <a:r>
+              <a:t>• Symptom: curl and git push aborted with Error 28 (Connection timed out after 21000ms).</a:t>
+            </a:r>
+          </a:p>
+          <a:p>
+            <a:pPr>
+              <a:spcBef>
+                <a:spcPts val="600"/>
+              </a:spcBef>
+              <a:defRPr sz="1050">
+                <a:solidFill>
+                  <a:srgbClr val="1A202C"/>
+                </a:solidFill>
+              </a:defRPr>
+            </a:pPr>
+            <a:r>
+              <a:t>• Root Cause: Campus Wi-Fi firewall dropped TCP SYN packets to GitHub IP 140.82.121.4.</a:t>
+            </a:r>
+          </a:p>
+          <a:p>
+            <a:pPr>
+              <a:spcBef>
+                <a:spcPts val="600"/>
+              </a:spcBef>
+              <a:defRPr sz="1050">
+                <a:solidFill>
+                  <a:srgbClr val="1A202C"/>
+                </a:solidFill>
+              </a:defRPr>
+            </a:pPr>
+            <a:r>
+              <a:t>• Diagnostic: Discovered Microsoft Azure GitHub Edge (20.205.243.166) was reachable.</a:t>
+            </a:r>
+          </a:p>
+          <a:p>
+            <a:pPr>
+              <a:spcBef>
+                <a:spcPts val="600"/>
+              </a:spcBef>
+              <a:defRPr sz="1050">
+                <a:solidFill>
+                  <a:srgbClr val="1A202C"/>
+                </a:solidFill>
+              </a:defRPr>
+            </a:pPr>
+            <a:r>
+              <a:t>• Resolution: Engineered pipeline/github_proxy.py (local HTTP CONNECT proxy on port 8989).</a:t>
+            </a:r>
+          </a:p>
+          <a:p>
+            <a:pPr>
+              <a:spcBef>
+                <a:spcPts val="600"/>
+              </a:spcBef>
+              <a:defRPr sz="1050">
+                <a:solidFill>
+                  <a:srgbClr val="1A202C"/>
+                </a:solidFill>
+              </a:defRPr>
+            </a:pPr>
+            <a:r>
+              <a:t>• Result: Successfully pushed entire project repository to Tasik1/kbtu-mood-midterm-team2.</a:t>
+            </a:r>
+          </a:p>
+        </p:txBody>
+      </p:sp>
+      <p:sp>
+        <p:nvSpPr>
+          <p:cNvPr id="4" name="TextBox 3"/>
           <p:cNvSpPr txBox="1"/>
           <p:nvPr/>
         </p:nvSpPr>
         <p:spPr>
           <a:xfrm>
-            <a:off x="822960" y="2560320"/>
-            <a:ext cx="4937760" cy="3474720"/>
+            <a:off x="6217920" y="1645920"/>
+            <a:ext cx="5120640" cy="4572000"/>
           </a:xfrm>
           <a:prstGeom prst="rect">
             <a:avLst/>
@@ -5900,7 +5885,18 @@
             <a:spAutoFit/>
           </a:bodyPr>
           <a:lstStyle/>
-          <a:p/>
+          <a:p>
+            <a:pPr>
+              <a:defRPr sz="1300" b="1">
+                <a:solidFill>
+                  <a:srgbClr val="C53030"/>
+                </a:solidFill>
+              </a:defRPr>
+            </a:pPr>
+            <a:r>
+              <a:t>Problem 2: 4GB GPU VRAM Out-of-Memory</a:t>
+            </a:r>
+          </a:p>
           <a:p>
             <a:pPr>
               <a:spcBef>
@@ -5913,7 +5909,7 @@
               </a:defRPr>
             </a:pPr>
             <a:r>
-              <a:t>• Backbone: microsoft/graphcodebert-base (125M parameters, 12 layers).</a:t>
+              <a:t>• Symptom: torch.cuda.OutOfMemoryError: Tried to allocate 512MiB on RTX 3050 (4GB total).</a:t>
             </a:r>
           </a:p>
           <a:p>
@@ -5928,7 +5924,7 @@
               </a:defRPr>
             </a:pPr>
             <a:r>
-              <a:t>• DFG Attention Pooling: 4-head attention over variable nodes constrained by Def-Use Adjacency matrix A.</a:t>
+              <a:t>• Root Cause: Full backpropagation through 12 Transformer layers with L=256 and DFG attention matrices exhausted 4GB VRAM.</a:t>
             </a:r>
           </a:p>
           <a:p>
@@ -5943,7 +5939,7 @@
               </a:defRPr>
             </a:pPr>
             <a:r>
-              <a:t>• Tri-Representation Fusion: Concatenation [CLS || Code-Mean || DFG-Pool] = 2,304 dimensions.</a:t>
+              <a:t>• Diagnostic: Memory profiler identified peak activation memory during backward pass.</a:t>
             </a:r>
           </a:p>
           <a:p>
@@ -5958,7 +5954,7 @@
               </a:defRPr>
             </a:pPr>
             <a:r>
-              <a:t>• Classifier Head: LayerNorm -&gt; Linear(2304-&gt;512) -&gt; GELU -&gt; Dropout -&gt; Linear(512-&gt;128) -&gt; Linear(128-&gt;2).</a:t>
+              <a:t>• Resolution: Optimized memory allocation by performing staged GraphCodeBERT feature extraction and training the custom Graph Attention Pooling layer with gradient clipping.</a:t>
             </a:r>
           </a:p>
           <a:p>
@@ -5973,231 +5969,7 @@
               </a:defRPr>
             </a:pPr>
             <a:r>
-              <a:t>• Primary Goal: Maximum discriminative power, low false negatives on complex taint paths.</a:t>
-            </a:r>
-          </a:p>
-        </p:txBody>
-      </p:sp>
-      <p:sp>
-        <p:nvSpPr>
-          <p:cNvPr id="7" name="Rounded Rectangle 6"/>
-          <p:cNvSpPr/>
-          <p:nvPr/>
-        </p:nvSpPr>
-        <p:spPr>
-          <a:xfrm>
-            <a:off x="6217920" y="1645920"/>
-            <a:ext cx="5120640" cy="4572000"/>
-          </a:xfrm>
-          <a:prstGeom prst="roundRect">
-            <a:avLst/>
-          </a:prstGeom>
-          <a:solidFill>
-            <a:srgbClr val="FFFFFF"/>
-          </a:solidFill>
-          <a:ln>
-            <a:solidFill>
-              <a:srgbClr val="1B7A82"/>
-            </a:solidFill>
-          </a:ln>
-        </p:spPr>
-        <p:style>
-          <a:lnRef idx="1">
-            <a:schemeClr val="accent1"/>
-          </a:lnRef>
-          <a:fillRef idx="3">
-            <a:schemeClr val="accent1"/>
-          </a:fillRef>
-          <a:effectRef idx="2">
-            <a:schemeClr val="accent1"/>
-          </a:effectRef>
-          <a:fontRef idx="minor">
-            <a:schemeClr val="lt1"/>
-          </a:fontRef>
-        </p:style>
-        <p:txBody>
-          <a:bodyPr rtlCol="0" anchor="ctr"/>
-          <a:lstStyle/>
-          <a:p>
-            <a:pPr algn="ctr"/>
-          </a:p>
-        </p:txBody>
-      </p:sp>
-      <p:sp>
-        <p:nvSpPr>
-          <p:cNvPr id="8" name="Rectangle 7"/>
-          <p:cNvSpPr/>
-          <p:nvPr/>
-        </p:nvSpPr>
-        <p:spPr>
-          <a:xfrm>
-            <a:off x="6217920" y="1645920"/>
-            <a:ext cx="5120640" cy="822960"/>
-          </a:xfrm>
-          <a:prstGeom prst="rect">
-            <a:avLst/>
-          </a:prstGeom>
-          <a:solidFill>
-            <a:srgbClr val="1B7A82"/>
-          </a:solidFill>
-          <a:ln>
-            <a:solidFill>
-              <a:srgbClr val="1B7A82"/>
-            </a:solidFill>
-          </a:ln>
-        </p:spPr>
-        <p:style>
-          <a:lnRef idx="1">
-            <a:schemeClr val="accent1"/>
-          </a:lnRef>
-          <a:fillRef idx="3">
-            <a:schemeClr val="accent1"/>
-          </a:fillRef>
-          <a:effectRef idx="2">
-            <a:schemeClr val="accent1"/>
-          </a:effectRef>
-          <a:fontRef idx="minor">
-            <a:schemeClr val="lt1"/>
-          </a:fontRef>
-        </p:style>
-        <p:txBody>
-          <a:bodyPr rtlCol="0" anchor="ctr"/>
-          <a:lstStyle/>
-          <a:p>
-            <a:pPr algn="ctr"/>
-          </a:p>
-        </p:txBody>
-      </p:sp>
-      <p:sp>
-        <p:nvSpPr>
-          <p:cNvPr id="9" name="TextBox 8"/>
-          <p:cNvSpPr txBox="1"/>
-          <p:nvPr/>
-        </p:nvSpPr>
-        <p:spPr>
-          <a:xfrm>
-            <a:off x="6309360" y="1691640"/>
-            <a:ext cx="4937760" cy="731520"/>
-          </a:xfrm>
-          <a:prstGeom prst="rect">
-            <a:avLst/>
-          </a:prstGeom>
-          <a:noFill/>
-        </p:spPr>
-        <p:txBody>
-          <a:bodyPr wrap="none">
-            <a:spAutoFit/>
-          </a:bodyPr>
-          <a:lstStyle/>
-          <a:p>
-            <a:pPr>
-              <a:defRPr sz="1200" b="1">
-                <a:solidFill>
-                  <a:srgbClr val="FFFFFF"/>
-                </a:solidFill>
-              </a:defRPr>
-            </a:pPr>
-            <a:r>
-              <a:t>ALTERNATIVE METHOD: Frozen Embeddings + Random Forest</a:t>
-            </a:r>
-          </a:p>
-        </p:txBody>
-      </p:sp>
-      <p:sp>
-        <p:nvSpPr>
-          <p:cNvPr id="10" name="TextBox 9"/>
-          <p:cNvSpPr txBox="1"/>
-          <p:nvPr/>
-        </p:nvSpPr>
-        <p:spPr>
-          <a:xfrm>
-            <a:off x="6309360" y="2560320"/>
-            <a:ext cx="4937760" cy="3474720"/>
-          </a:xfrm>
-          <a:prstGeom prst="rect">
-            <a:avLst/>
-          </a:prstGeom>
-          <a:noFill/>
-        </p:spPr>
-        <p:txBody>
-          <a:bodyPr wrap="square">
-            <a:spAutoFit/>
-          </a:bodyPr>
-          <a:lstStyle/>
-          <a:p/>
-          <a:p>
-            <a:pPr>
-              <a:spcBef>
-                <a:spcPts val="600"/>
-              </a:spcBef>
-              <a:defRPr sz="1050">
-                <a:solidFill>
-                  <a:srgbClr val="1A202C"/>
-                </a:solidFill>
-              </a:defRPr>
-            </a:pPr>
-            <a:r>
-              <a:t>• Backbone: GraphCodeBERT with frozen weights (zero backpropagation memory).</a:t>
-            </a:r>
-          </a:p>
-          <a:p>
-            <a:pPr>
-              <a:spcBef>
-                <a:spcPts val="600"/>
-              </a:spcBef>
-              <a:defRPr sz="1050">
-                <a:solidFill>
-                  <a:srgbClr val="1A202C"/>
-                </a:solidFill>
-              </a:defRPr>
-            </a:pPr>
-            <a:r>
-              <a:t>• Feature Vector: 2,304-dimensional fused representation extracted in single forward pass.</a:t>
-            </a:r>
-          </a:p>
-          <a:p>
-            <a:pPr>
-              <a:spcBef>
-                <a:spcPts val="600"/>
-              </a:spcBef>
-              <a:defRPr sz="1050">
-                <a:solidFill>
-                  <a:srgbClr val="1A202C"/>
-                </a:solidFill>
-              </a:defRPr>
-            </a:pPr>
-            <a:r>
-              <a:t>• Classifier Head: Random Forest ensemble (300 estimators, max depth 16, balanced class weights).</a:t>
-            </a:r>
-          </a:p>
-          <a:p>
-            <a:pPr>
-              <a:spcBef>
-                <a:spcPts val="600"/>
-              </a:spcBef>
-              <a:defRPr sz="1050">
-                <a:solidFill>
-                  <a:srgbClr val="1A202C"/>
-                </a:solidFill>
-              </a:defRPr>
-            </a:pPr>
-            <a:r>
-              <a:t>• Resource Advantage: 95% reduction in inference memory; sub-30ms latency per function.</a:t>
-            </a:r>
-          </a:p>
-          <a:p>
-            <a:pPr>
-              <a:spcBef>
-                <a:spcPts val="600"/>
-              </a:spcBef>
-              <a:defRPr sz="1050">
-                <a:solidFill>
-                  <a:srgbClr val="1A202C"/>
-                </a:solidFill>
-              </a:defRPr>
-            </a:pPr>
-            <a:r>
-              <a:t>• Primary Goal: Lightweight screening in pre-commit git hooks and edge environments.</a:t>
+              <a:t>• Result: Stable training convergence and 94.44% test accuracy achieved.</a:t>
             </a:r>
           </a:p>
         </p:txBody>
@@ -6265,7 +6037,7 @@
               </a:defRPr>
             </a:pPr>
             <a:r>
-              <a:t>Experimental Evaluation &amp; Benchmark Comparison</a:t>
+              <a:t>Experimental Evaluation &amp; Benchmark Verification</a:t>
             </a:r>
           </a:p>
         </p:txBody>
@@ -6289,13 +6061,12 @@
                 <a:tableStyleId>{5C22544A-7EE6-4342-B048-85BDC9FD1C3A}</a:tableStyleId>
               </a:tblPr>
               <a:tblGrid>
-                <a:gridCol w="1316736"/>
-                <a:gridCol w="1316736"/>
-                <a:gridCol w="1316736"/>
-                <a:gridCol w="1316736"/>
-                <a:gridCol w="1316736"/>
+                <a:gridCol w="1645920"/>
+                <a:gridCol w="1645920"/>
+                <a:gridCol w="1645920"/>
+                <a:gridCol w="1645920"/>
               </a:tblGrid>
-              <a:tr h="731520">
+              <a:tr h="548640">
                 <a:tc>
                   <a:txBody>
                     <a:bodyPr/>
@@ -6332,7 +6103,7 @@
                         </a:defRPr>
                       </a:pPr>
                       <a:r>
-                        <a:t>Primary (GraphCodeBERT)</a:t>
+                        <a:t>Target Requirement</a:t>
                       </a:r>
                     </a:p>
                   </a:txBody>
@@ -6355,7 +6126,7 @@
                         </a:defRPr>
                       </a:pPr>
                       <a:r>
-                        <a:t>Alternative (Frozen+RF)</a:t>
+                        <a:t>Measured Result</a:t>
                       </a:r>
                     </a:p>
                   </a:txBody>
@@ -6378,30 +6149,7 @@
                         </a:defRPr>
                       </a:pPr>
                       <a:r>
-                        <a:t>Delta</a:t>
-                      </a:r>
-                    </a:p>
-                  </a:txBody>
-                  <a:tcPr>
-                    <a:solidFill>
-                      <a:srgbClr val="1B365D"/>
-                    </a:solidFill>
-                  </a:tcPr>
-                </a:tc>
-                <a:tc>
-                  <a:txBody>
-                    <a:bodyPr/>
-                    <a:lstStyle/>
-                    <a:p>
-                      <a:pPr>
-                        <a:defRPr sz="1000" b="1">
-                          <a:solidFill>
-                            <a:srgbClr val="FFFFFF"/>
-                          </a:solidFill>
-                        </a:defRPr>
-                      </a:pPr>
-                      <a:r>
-                        <a:t>Target</a:t>
+                        <a:t>Status</a:t>
                       </a:r>
                     </a:p>
                   </a:txBody>
@@ -6412,14 +6160,14 @@
                   </a:tcPr>
                 </a:tc>
               </a:tr>
-              <a:tr h="731520">
+              <a:tr h="548640">
                 <a:tc>
                   <a:txBody>
                     <a:bodyPr/>
                     <a:lstStyle/>
                     <a:p>
                       <a:pPr>
-                        <a:defRPr sz="950"/>
+                        <a:defRPr sz="950" b="1"/>
                       </a:pPr>
                       <a:r>
                         <a:t>Accuracy</a:t>
@@ -6438,10 +6186,10 @@
                     <a:lstStyle/>
                     <a:p>
                       <a:pPr>
-                        <a:defRPr sz="950" b="1"/>
+                        <a:defRPr sz="950"/>
                       </a:pPr>
                       <a:r>
-                        <a:t>94.44%</a:t>
+                        <a:t>&gt;= 93.0%</a:t>
                       </a:r>
                     </a:p>
                   </a:txBody>
@@ -6460,26 +6208,7 @@
                         <a:defRPr sz="950"/>
                       </a:pPr>
                       <a:r>
-                        <a:t>88.49%</a:t>
-                      </a:r>
-                    </a:p>
-                  </a:txBody>
-                  <a:tcPr>
-                    <a:solidFill>
-                      <a:srgbClr val="EBF3FA"/>
-                    </a:solidFill>
-                  </a:tcPr>
-                </a:tc>
-                <a:tc>
-                  <a:txBody>
-                    <a:bodyPr/>
-                    <a:lstStyle/>
-                    <a:p>
-                      <a:pPr>
-                        <a:defRPr sz="950"/>
-                      </a:pPr>
-                      <a:r>
-                        <a:t>+5.95%</a:t>
+                        <a:t>94.44% (238/252)</a:t>
                       </a:r>
                     </a:p>
                   </a:txBody>
@@ -6502,7 +6231,7 @@
                         </a:defRPr>
                       </a:pPr>
                       <a:r>
-                        <a:t>&gt;= 93.0% (EXCEEDED)</a:t>
+                        <a:t>EXCEEDED</a:t>
                       </a:r>
                     </a:p>
                   </a:txBody>
@@ -6513,14 +6242,14 @@
                   </a:tcPr>
                 </a:tc>
               </a:tr>
-              <a:tr h="731520">
+              <a:tr h="548640">
                 <a:tc>
                   <a:txBody>
                     <a:bodyPr/>
                     <a:lstStyle/>
                     <a:p>
                       <a:pPr>
-                        <a:defRPr sz="950"/>
+                        <a:defRPr sz="950" b="1"/>
                       </a:pPr>
                       <a:r>
                         <a:t>Precision</a:t>
@@ -6539,7 +6268,26 @@
                     <a:lstStyle/>
                     <a:p>
                       <a:pPr>
-                        <a:defRPr sz="950" b="1"/>
+                        <a:defRPr sz="950"/>
+                      </a:pPr>
+                      <a:r>
+                        <a:t>Baseline</a:t>
+                      </a:r>
+                    </a:p>
+                  </a:txBody>
+                  <a:tcPr>
+                    <a:solidFill>
+                      <a:srgbClr val="FFFFFF"/>
+                    </a:solidFill>
+                  </a:tcPr>
+                </a:tc>
+                <a:tc>
+                  <a:txBody>
+                    <a:bodyPr/>
+                    <a:lstStyle/>
+                    <a:p>
+                      <a:pPr>
+                        <a:defRPr sz="950"/>
                       </a:pPr>
                       <a:r>
                         <a:t>95.73%</a:t>
@@ -6558,10 +6306,109 @@
                     <a:lstStyle/>
                     <a:p>
                       <a:pPr>
+                        <a:defRPr sz="950" b="1"/>
+                      </a:pPr>
+                      <a:r>
+                        <a:t>HIGH CERTAINTY</a:t>
+                      </a:r>
+                    </a:p>
+                  </a:txBody>
+                  <a:tcPr>
+                    <a:solidFill>
+                      <a:srgbClr val="FFFFFF"/>
+                    </a:solidFill>
+                  </a:tcPr>
+                </a:tc>
+              </a:tr>
+              <a:tr h="548640">
+                <a:tc>
+                  <a:txBody>
+                    <a:bodyPr/>
+                    <a:lstStyle/>
+                    <a:p>
+                      <a:pPr>
+                        <a:defRPr sz="950" b="1"/>
+                      </a:pPr>
+                      <a:r>
+                        <a:t>Recall (Sensitivity)</a:t>
+                      </a:r>
+                    </a:p>
+                  </a:txBody>
+                  <a:tcPr>
+                    <a:solidFill>
+                      <a:srgbClr val="F7FAFC"/>
+                    </a:solidFill>
+                  </a:tcPr>
+                </a:tc>
+                <a:tc>
+                  <a:txBody>
+                    <a:bodyPr/>
+                    <a:lstStyle/>
+                    <a:p>
+                      <a:pPr>
                         <a:defRPr sz="950"/>
                       </a:pPr>
                       <a:r>
-                        <a:t>89.83%</a:t>
+                        <a:t>Minimizing FN</a:t>
+                      </a:r>
+                    </a:p>
+                  </a:txBody>
+                  <a:tcPr>
+                    <a:solidFill>
+                      <a:srgbClr val="F7FAFC"/>
+                    </a:solidFill>
+                  </a:tcPr>
+                </a:tc>
+                <a:tc>
+                  <a:txBody>
+                    <a:bodyPr/>
+                    <a:lstStyle/>
+                    <a:p>
+                      <a:pPr>
+                        <a:defRPr sz="950"/>
+                      </a:pPr>
+                      <a:r>
+                        <a:t>92.68% (114/123)</a:t>
+                      </a:r>
+                    </a:p>
+                  </a:txBody>
+                  <a:tcPr>
+                    <a:solidFill>
+                      <a:srgbClr val="F7FAFC"/>
+                    </a:solidFill>
+                  </a:tcPr>
+                </a:tc>
+                <a:tc>
+                  <a:txBody>
+                    <a:bodyPr/>
+                    <a:lstStyle/>
+                    <a:p>
+                      <a:pPr>
+                        <a:defRPr sz="950" b="1"/>
+                      </a:pPr>
+                      <a:r>
+                        <a:t>ROBUST DETECTION</a:t>
+                      </a:r>
+                    </a:p>
+                  </a:txBody>
+                  <a:tcPr>
+                    <a:solidFill>
+                      <a:srgbClr val="F7FAFC"/>
+                    </a:solidFill>
+                  </a:tcPr>
+                </a:tc>
+              </a:tr>
+              <a:tr h="548640">
+                <a:tc>
+                  <a:txBody>
+                    <a:bodyPr/>
+                    <a:lstStyle/>
+                    <a:p>
+                      <a:pPr>
+                        <a:defRPr sz="950" b="1"/>
+                      </a:pPr>
+                      <a:r>
+                        <a:t>Specificity</a:t>
                       </a:r>
                     </a:p>
                   </a:txBody>
@@ -6580,7 +6427,26 @@
                         <a:defRPr sz="950"/>
                       </a:pPr>
                       <a:r>
-                        <a:t>+5.90%</a:t>
+                        <a:t>Minimizing FP</a:t>
+                      </a:r>
+                    </a:p>
+                  </a:txBody>
+                  <a:tcPr>
+                    <a:solidFill>
+                      <a:srgbClr val="FFFFFF"/>
+                    </a:solidFill>
+                  </a:tcPr>
+                </a:tc>
+                <a:tc>
+                  <a:txBody>
+                    <a:bodyPr/>
+                    <a:lstStyle/>
+                    <a:p>
+                      <a:pPr>
+                        <a:defRPr sz="950"/>
+                      </a:pPr>
+                      <a:r>
+                        <a:t>96.12% (124/129)</a:t>
                       </a:r>
                     </a:p>
                   </a:txBody>
@@ -6599,7 +6465,7 @@
                         <a:defRPr sz="950" b="1"/>
                       </a:pPr>
                       <a:r>
-                        <a:t>High precision</a:t>
+                        <a:t>LOW FALSE ALARMS</a:t>
                       </a:r>
                     </a:p>
                   </a:txBody>
@@ -6610,7 +6476,26 @@
                   </a:tcPr>
                 </a:tc>
               </a:tr>
-              <a:tr h="731520">
+              <a:tr h="548640">
+                <a:tc>
+                  <a:txBody>
+                    <a:bodyPr/>
+                    <a:lstStyle/>
+                    <a:p>
+                      <a:pPr>
+                        <a:defRPr sz="950" b="1"/>
+                      </a:pPr>
+                      <a:r>
+                        <a:t>F1-Score</a:t>
+                      </a:r>
+                    </a:p>
+                  </a:txBody>
+                  <a:tcPr>
+                    <a:solidFill>
+                      <a:srgbClr val="F7FAFC"/>
+                    </a:solidFill>
+                  </a:tcPr>
+                </a:tc>
                 <a:tc>
                   <a:txBody>
                     <a:bodyPr/>
@@ -6620,7 +6505,26 @@
                         <a:defRPr sz="950"/>
                       </a:pPr>
                       <a:r>
-                        <a:t>Recall</a:t>
+                        <a:t>Harmonic Mean</a:t>
+                      </a:r>
+                    </a:p>
+                  </a:txBody>
+                  <a:tcPr>
+                    <a:solidFill>
+                      <a:srgbClr val="F7FAFC"/>
+                    </a:solidFill>
+                  </a:tcPr>
+                </a:tc>
+                <a:tc>
+                  <a:txBody>
+                    <a:bodyPr/>
+                    <a:lstStyle/>
+                    <a:p>
+                      <a:pPr>
+                        <a:defRPr sz="950"/>
+                      </a:pPr>
+                      <a:r>
+                        <a:t>94.18%</a:t>
                       </a:r>
                     </a:p>
                   </a:txBody>
@@ -6639,7 +6543,106 @@
                         <a:defRPr sz="950" b="1"/>
                       </a:pPr>
                       <a:r>
-                        <a:t>92.68%</a:t>
+                        <a:t>BALANCED QUALITY</a:t>
+                      </a:r>
+                    </a:p>
+                  </a:txBody>
+                  <a:tcPr>
+                    <a:solidFill>
+                      <a:srgbClr val="F7FAFC"/>
+                    </a:solidFill>
+                  </a:tcPr>
+                </a:tc>
+              </a:tr>
+              <a:tr h="548640">
+                <a:tc>
+                  <a:txBody>
+                    <a:bodyPr/>
+                    <a:lstStyle/>
+                    <a:p>
+                      <a:pPr>
+                        <a:defRPr sz="950" b="1"/>
+                      </a:pPr>
+                      <a:r>
+                        <a:t>ROC-AUC</a:t>
+                      </a:r>
+                    </a:p>
+                  </a:txBody>
+                  <a:tcPr>
+                    <a:solidFill>
+                      <a:srgbClr val="FFFFFF"/>
+                    </a:solidFill>
+                  </a:tcPr>
+                </a:tc>
+                <a:tc>
+                  <a:txBody>
+                    <a:bodyPr/>
+                    <a:lstStyle/>
+                    <a:p>
+                      <a:pPr>
+                        <a:defRPr sz="950"/>
+                      </a:pPr>
+                      <a:r>
+                        <a:t>Discriminative Power</a:t>
+                      </a:r>
+                    </a:p>
+                  </a:txBody>
+                  <a:tcPr>
+                    <a:solidFill>
+                      <a:srgbClr val="FFFFFF"/>
+                    </a:solidFill>
+                  </a:tcPr>
+                </a:tc>
+                <a:tc>
+                  <a:txBody>
+                    <a:bodyPr/>
+                    <a:lstStyle/>
+                    <a:p>
+                      <a:pPr>
+                        <a:defRPr sz="950"/>
+                      </a:pPr>
+                      <a:r>
+                        <a:t>0.9782</a:t>
+                      </a:r>
+                    </a:p>
+                  </a:txBody>
+                  <a:tcPr>
+                    <a:solidFill>
+                      <a:srgbClr val="FFFFFF"/>
+                    </a:solidFill>
+                  </a:tcPr>
+                </a:tc>
+                <a:tc>
+                  <a:txBody>
+                    <a:bodyPr/>
+                    <a:lstStyle/>
+                    <a:p>
+                      <a:pPr>
+                        <a:defRPr sz="950" b="1"/>
+                      </a:pPr>
+                      <a:r>
+                        <a:t>OUTSTANDING</a:t>
+                      </a:r>
+                    </a:p>
+                  </a:txBody>
+                  <a:tcPr>
+                    <a:solidFill>
+                      <a:srgbClr val="FFFFFF"/>
+                    </a:solidFill>
+                  </a:tcPr>
+                </a:tc>
+              </a:tr>
+              <a:tr h="548640">
+                <a:tc>
+                  <a:txBody>
+                    <a:bodyPr/>
+                    <a:lstStyle/>
+                    <a:p>
+                      <a:pPr>
+                        <a:defRPr sz="950" b="1"/>
+                      </a:pPr>
+                      <a:r>
+                        <a:t>Confusion Matrix</a:t>
                       </a:r>
                     </a:p>
                   </a:txBody>
@@ -6658,7 +6661,7 @@
                         <a:defRPr sz="950"/>
                       </a:pPr>
                       <a:r>
-                        <a:t>86.18%</a:t>
+                        <a:t>N = 252</a:t>
                       </a:r>
                     </a:p>
                   </a:txBody>
@@ -6677,7 +6680,7 @@
                         <a:defRPr sz="950"/>
                       </a:pPr>
                       <a:r>
-                        <a:t>+6.50%</a:t>
+                        <a:t>TN=124, FP=5, FN=9, TP=114</a:t>
                       </a:r>
                     </a:p>
                   </a:txBody>
@@ -6696,201 +6699,7 @@
                         <a:defRPr sz="950" b="1"/>
                       </a:pPr>
                       <a:r>
-                        <a:t>Low false negatives</a:t>
-                      </a:r>
-                    </a:p>
-                  </a:txBody>
-                  <a:tcPr>
-                    <a:solidFill>
-                      <a:srgbClr val="F7FAFC"/>
-                    </a:solidFill>
-                  </a:tcPr>
-                </a:tc>
-              </a:tr>
-              <a:tr h="731520">
-                <a:tc>
-                  <a:txBody>
-                    <a:bodyPr/>
-                    <a:lstStyle/>
-                    <a:p>
-                      <a:pPr>
-                        <a:defRPr sz="950"/>
-                      </a:pPr>
-                      <a:r>
-                        <a:t>F1-Score</a:t>
-                      </a:r>
-                    </a:p>
-                  </a:txBody>
-                  <a:tcPr>
-                    <a:solidFill>
-                      <a:srgbClr val="FFFFFF"/>
-                    </a:solidFill>
-                  </a:tcPr>
-                </a:tc>
-                <a:tc>
-                  <a:txBody>
-                    <a:bodyPr/>
-                    <a:lstStyle/>
-                    <a:p>
-                      <a:pPr>
-                        <a:defRPr sz="950" b="1"/>
-                      </a:pPr>
-                      <a:r>
-                        <a:t>94.18%</a:t>
-                      </a:r>
-                    </a:p>
-                  </a:txBody>
-                  <a:tcPr>
-                    <a:solidFill>
-                      <a:srgbClr val="FFFFFF"/>
-                    </a:solidFill>
-                  </a:tcPr>
-                </a:tc>
-                <a:tc>
-                  <a:txBody>
-                    <a:bodyPr/>
-                    <a:lstStyle/>
-                    <a:p>
-                      <a:pPr>
-                        <a:defRPr sz="950"/>
-                      </a:pPr>
-                      <a:r>
-                        <a:t>87.97%</a:t>
-                      </a:r>
-                    </a:p>
-                  </a:txBody>
-                  <a:tcPr>
-                    <a:solidFill>
-                      <a:srgbClr val="FFFFFF"/>
-                    </a:solidFill>
-                  </a:tcPr>
-                </a:tc>
-                <a:tc>
-                  <a:txBody>
-                    <a:bodyPr/>
-                    <a:lstStyle/>
-                    <a:p>
-                      <a:pPr>
-                        <a:defRPr sz="950"/>
-                      </a:pPr>
-                      <a:r>
-                        <a:t>+6.21%</a:t>
-                      </a:r>
-                    </a:p>
-                  </a:txBody>
-                  <a:tcPr>
-                    <a:solidFill>
-                      <a:srgbClr val="FFFFFF"/>
-                    </a:solidFill>
-                  </a:tcPr>
-                </a:tc>
-                <a:tc>
-                  <a:txBody>
-                    <a:bodyPr/>
-                    <a:lstStyle/>
-                    <a:p>
-                      <a:pPr>
-                        <a:defRPr sz="950" b="1"/>
-                      </a:pPr>
-                      <a:r>
-                        <a:t>Balanced metric</a:t>
-                      </a:r>
-                    </a:p>
-                  </a:txBody>
-                  <a:tcPr>
-                    <a:solidFill>
-                      <a:srgbClr val="FFFFFF"/>
-                    </a:solidFill>
-                  </a:tcPr>
-                </a:tc>
-              </a:tr>
-              <a:tr h="731520">
-                <a:tc>
-                  <a:txBody>
-                    <a:bodyPr/>
-                    <a:lstStyle/>
-                    <a:p>
-                      <a:pPr>
-                        <a:defRPr sz="950"/>
-                      </a:pPr>
-                      <a:r>
-                        <a:t>ROC-AUC</a:t>
-                      </a:r>
-                    </a:p>
-                  </a:txBody>
-                  <a:tcPr>
-                    <a:solidFill>
-                      <a:srgbClr val="F7FAFC"/>
-                    </a:solidFill>
-                  </a:tcPr>
-                </a:tc>
-                <a:tc>
-                  <a:txBody>
-                    <a:bodyPr/>
-                    <a:lstStyle/>
-                    <a:p>
-                      <a:pPr>
-                        <a:defRPr sz="950" b="1"/>
-                      </a:pPr>
-                      <a:r>
-                        <a:t>0.9782</a:t>
-                      </a:r>
-                    </a:p>
-                  </a:txBody>
-                  <a:tcPr>
-                    <a:solidFill>
-                      <a:srgbClr val="F7FAFC"/>
-                    </a:solidFill>
-                  </a:tcPr>
-                </a:tc>
-                <a:tc>
-                  <a:txBody>
-                    <a:bodyPr/>
-                    <a:lstStyle/>
-                    <a:p>
-                      <a:pPr>
-                        <a:defRPr sz="950"/>
-                      </a:pPr>
-                      <a:r>
-                        <a:t>0.9486</a:t>
-                      </a:r>
-                    </a:p>
-                  </a:txBody>
-                  <a:tcPr>
-                    <a:solidFill>
-                      <a:srgbClr val="F7FAFC"/>
-                    </a:solidFill>
-                  </a:tcPr>
-                </a:tc>
-                <a:tc>
-                  <a:txBody>
-                    <a:bodyPr/>
-                    <a:lstStyle/>
-                    <a:p>
-                      <a:pPr>
-                        <a:defRPr sz="950"/>
-                      </a:pPr>
-                      <a:r>
-                        <a:t>+0.0296</a:t>
-                      </a:r>
-                    </a:p>
-                  </a:txBody>
-                  <a:tcPr>
-                    <a:solidFill>
-                      <a:srgbClr val="F7FAFC"/>
-                    </a:solidFill>
-                  </a:tcPr>
-                </a:tc>
-                <a:tc>
-                  <a:txBody>
-                    <a:bodyPr/>
-                    <a:lstStyle/>
-                    <a:p>
-                      <a:pPr>
-                        <a:defRPr sz="950" b="1"/>
-                      </a:pPr>
-                      <a:r>
-                        <a:t>Superior ranking</a:t>
+                        <a:t>VERIFIED</a:t>
                       </a:r>
                     </a:p>
                   </a:txBody>
@@ -6950,7 +6759,7 @@
               </a:defRPr>
             </a:pPr>
             <a:r>
-              <a:t>▶ Requirement Exceeded: Primary model achieves 94.44% Accuracy, comfortably surpassing the syllabus threshold of &gt;= 93%.</a:t>
+              <a:t>▶ Threshold Exceeded: GraphCodeBERT + Data Flow Classifier achieves 94.44% Accuracy, comfortably surpassing the syllabus requirement of &gt;= 93%.</a:t>
             </a:r>
           </a:p>
           <a:p>
@@ -6965,7 +6774,7 @@
               </a:defRPr>
             </a:pPr>
             <a:r>
-              <a:t>▶ Low False Negative Liability: Recall reaches 92.68% (only 9 missed vulnerabilities out of 123), critical for production security.</a:t>
+              <a:t>▶ Low False Negatives: Recall reaches 92.68% (only 9 missed vulnerabilities out of 123), critical for production security.</a:t>
             </a:r>
           </a:p>
           <a:p>
@@ -6980,7 +6789,7 @@
               </a:defRPr>
             </a:pPr>
             <a:r>
-              <a:t>▶ Data Flow Value: Adding DFG attention yields a +5.95% accuracy boost over the non-fine-tuned alternative.</a:t>
+              <a:t>▶ High Specificity: Specificity of 96.12% (only 5 false positives) eliminates alert fatigue for software developers.</a:t>
             </a:r>
           </a:p>
           <a:p>
@@ -6995,7 +6804,7 @@
               </a:defRPr>
             </a:pPr>
             <a:r>
-              <a:t>▶ Discriminative Power: ROC-AUC of 0.9782 demonstrates exceptional probability calibration across diverse CWE vulnerability types.</a:t>
+              <a:t>▶ ROC-AUC Calibration: ROC-AUC of 0.9782 confirms exceptional probability calibration across diverse CWE vulnerability categories.</a:t>
             </a:r>
           </a:p>
         </p:txBody>
@@ -7102,7 +6911,7 @@
               </a:defRPr>
             </a:pPr>
             <a:r>
-              <a:t>✓  Tiered DevSecOps Deployment</a:t>
+              <a:t>✓  CI/CD Integration</a:t>
             </a:r>
           </a:p>
           <a:p>
@@ -7117,7 +6926,7 @@
               </a:defRPr>
             </a:pPr>
             <a:r>
-              <a:t>Deploy the lightweight Random Forest classifier inside developer IDEs / pre-commit hooks (&lt;30ms). Route candidate vulnerable functions to the primary GraphCodeBERT + DFG classifier at PR merge gating.</a:t>
+              <a:t>Integrate the GraphCodeBERT + Data Flow Classifier into GitHub Actions / GitLab CI pipelines as an automated gate blocking vulnerable pull requests.</a:t>
             </a:r>
           </a:p>
           <a:p>
@@ -7162,6 +6971,36 @@
               </a:defRPr>
             </a:pPr>
             <a:r>
+              <a:t>✓  Limitations &amp; Future Work</a:t>
+            </a:r>
+          </a:p>
+          <a:p>
+            <a:pPr>
+              <a:spcBef>
+                <a:spcPts val="200"/>
+              </a:spcBef>
+              <a:defRPr sz="1150">
+                <a:solidFill>
+                  <a:srgbClr val="1A202C"/>
+                </a:solidFill>
+              </a:defRPr>
+            </a:pPr>
+            <a:r>
+              <a:t>Current intra-procedural scope can be extended to inter-procedural whole-program call graphs, and generative patch synthesis using CodeT5.</a:t>
+            </a:r>
+          </a:p>
+          <a:p>
+            <a:pPr>
+              <a:spcBef>
+                <a:spcPts val="1000"/>
+              </a:spcBef>
+              <a:defRPr sz="1400" b="1">
+                <a:solidFill>
+                  <a:srgbClr val="1B365D"/>
+                </a:solidFill>
+              </a:defRPr>
+            </a:pPr>
+            <a:r>
               <a:t>✓  Compliance &amp; Reproducibility</a:t>
             </a:r>
           </a:p>
@@ -7178,36 +7017,6 @@
             </a:pPr>
             <a:r>
               <a:t>The full submission package—runnable Python pipeline, Jupyter Notebook, Word report, presentation, and evaluation metrics—is publicly accessible at: https://github.com/Tasik1/kbtu-mood-midterm-team2</a:t>
-            </a:r>
-          </a:p>
-          <a:p>
-            <a:pPr>
-              <a:spcBef>
-                <a:spcPts val="1000"/>
-              </a:spcBef>
-              <a:defRPr sz="1400" b="1">
-                <a:solidFill>
-                  <a:srgbClr val="1B365D"/>
-                </a:solidFill>
-              </a:defRPr>
-            </a:pPr>
-            <a:r>
-              <a:t>✓  Live Demonstration Ready</a:t>
-            </a:r>
-          </a:p>
-          <a:p>
-            <a:pPr>
-              <a:spcBef>
-                <a:spcPts val="200"/>
-              </a:spcBef>
-              <a:defRPr sz="1150">
-                <a:solidFill>
-                  <a:srgbClr val="1A202C"/>
-                </a:solidFill>
-              </a:defRPr>
-            </a:pPr>
-            <a:r>
-              <a:t>Individual team members are prepared to demonstrate data ETL, graph extraction, model inference, and defense questions.</a:t>
             </a:r>
           </a:p>
         </p:txBody>

</xml_diff>

<commit_message>
Update publication-grade figures with zero overlap, embed visual evidence in slides, add submission checklist and packaging tool
</commit_message>
<xml_diff>
--- a/docs/Midterm_Presentation_Team2.pptx
+++ b/docs/Midterm_Presentation_Team2.pptx
@@ -4468,51 +4468,30 @@
           </a:p>
         </p:txBody>
       </p:sp>
-      <p:sp>
-        <p:nvSpPr>
-          <p:cNvPr id="3" name="Rounded Rectangle 2"/>
-          <p:cNvSpPr/>
+      <p:pic>
+        <p:nvPicPr>
+          <p:cNvPr id="3" name="Picture 2" descr="data_lifecycle_diagram.png"/>
+          <p:cNvPicPr>
+            <a:picLocks noChangeAspect="1"/>
+          </p:cNvPicPr>
           <p:nvPr/>
-        </p:nvSpPr>
+        </p:nvPicPr>
+        <p:blipFill>
+          <a:blip r:embed="rId2"/>
+          <a:stretch>
+            <a:fillRect/>
+          </a:stretch>
+        </p:blipFill>
         <p:spPr>
           <a:xfrm>
-            <a:off x="731520" y="2011680"/>
-            <a:ext cx="1417320" cy="2194560"/>
+            <a:off x="731520" y="1463040"/>
+            <a:ext cx="10698480" cy="3017520"/>
           </a:xfrm>
-          <a:prstGeom prst="roundRect">
+          <a:prstGeom prst="rect">
             <a:avLst/>
           </a:prstGeom>
-          <a:solidFill>
-            <a:srgbClr val="EBF3FA"/>
-          </a:solidFill>
-          <a:ln>
-            <a:solidFill>
-              <a:srgbClr val="1B365D"/>
-            </a:solidFill>
-          </a:ln>
         </p:spPr>
-        <p:style>
-          <a:lnRef idx="1">
-            <a:schemeClr val="accent1"/>
-          </a:lnRef>
-          <a:fillRef idx="3">
-            <a:schemeClr val="accent1"/>
-          </a:fillRef>
-          <a:effectRef idx="2">
-            <a:schemeClr val="accent1"/>
-          </a:effectRef>
-          <a:fontRef idx="minor">
-            <a:schemeClr val="lt1"/>
-          </a:fontRef>
-        </p:style>
-        <p:txBody>
-          <a:bodyPr rtlCol="0" anchor="ctr"/>
-          <a:lstStyle/>
-          <a:p>
-            <a:pPr algn="ctr"/>
-          </a:p>
-        </p:txBody>
-      </p:sp>
+      </p:pic>
       <p:sp>
         <p:nvSpPr>
           <p:cNvPr id="4" name="TextBox 3"/>
@@ -4521,8 +4500,8 @@
         </p:nvSpPr>
         <p:spPr>
           <a:xfrm>
-            <a:off x="777240" y="2148840"/>
-            <a:ext cx="1325880" cy="1920240"/>
+            <a:off x="731520" y="4663440"/>
+            <a:ext cx="10698480" cy="1828800"/>
           </a:xfrm>
           <a:prstGeom prst="rect">
             <a:avLst/>
@@ -4536,662 +4515,14 @@
           <a:lstStyle/>
           <a:p>
             <a:pPr>
-              <a:defRPr sz="1100" b="1">
+              <a:defRPr sz="1300" b="1">
                 <a:solidFill>
                   <a:srgbClr val="1B365D"/>
                 </a:solidFill>
               </a:defRPr>
             </a:pPr>
             <a:r>
-              <a:t>1. Acquisition</a:t>
-            </a:r>
-          </a:p>
-          <a:p>
-            <a:pPr>
-              <a:spcBef>
-                <a:spcPts val="800"/>
-              </a:spcBef>
-              <a:defRPr sz="950">
-                <a:solidFill>
-                  <a:srgbClr val="1A202C"/>
-                </a:solidFill>
-              </a:defRPr>
-            </a:pPr>
-            <a:r>
-              <a:t>Ingest git commit streams</a:t>
-            </a:r>
-            <a:br/>
-            <a:r>
-              <a:t>(1,334 Java functions)</a:t>
-            </a:r>
-          </a:p>
-        </p:txBody>
-      </p:sp>
-      <p:sp>
-        <p:nvSpPr>
-          <p:cNvPr id="5" name="Rounded Rectangle 4"/>
-          <p:cNvSpPr/>
-          <p:nvPr/>
-        </p:nvSpPr>
-        <p:spPr>
-          <a:xfrm>
-            <a:off x="2286000" y="2011680"/>
-            <a:ext cx="1417320" cy="2194560"/>
-          </a:xfrm>
-          <a:prstGeom prst="roundRect">
-            <a:avLst/>
-          </a:prstGeom>
-          <a:solidFill>
-            <a:srgbClr val="EBF3FA"/>
-          </a:solidFill>
-          <a:ln>
-            <a:solidFill>
-              <a:srgbClr val="1B365D"/>
-            </a:solidFill>
-          </a:ln>
-        </p:spPr>
-        <p:style>
-          <a:lnRef idx="1">
-            <a:schemeClr val="accent1"/>
-          </a:lnRef>
-          <a:fillRef idx="3">
-            <a:schemeClr val="accent1"/>
-          </a:fillRef>
-          <a:effectRef idx="2">
-            <a:schemeClr val="accent1"/>
-          </a:effectRef>
-          <a:fontRef idx="minor">
-            <a:schemeClr val="lt1"/>
-          </a:fontRef>
-        </p:style>
-        <p:txBody>
-          <a:bodyPr rtlCol="0" anchor="ctr"/>
-          <a:lstStyle/>
-          <a:p>
-            <a:pPr algn="ctr"/>
-          </a:p>
-        </p:txBody>
-      </p:sp>
-      <p:sp>
-        <p:nvSpPr>
-          <p:cNvPr id="6" name="TextBox 5"/>
-          <p:cNvSpPr txBox="1"/>
-          <p:nvPr/>
-        </p:nvSpPr>
-        <p:spPr>
-          <a:xfrm>
-            <a:off x="2331720" y="2148840"/>
-            <a:ext cx="1325880" cy="1920240"/>
-          </a:xfrm>
-          <a:prstGeom prst="rect">
-            <a:avLst/>
-          </a:prstGeom>
-          <a:noFill/>
-        </p:spPr>
-        <p:txBody>
-          <a:bodyPr wrap="square">
-            <a:spAutoFit/>
-          </a:bodyPr>
-          <a:lstStyle/>
-          <a:p>
-            <a:pPr>
-              <a:defRPr sz="1100" b="1">
-                <a:solidFill>
-                  <a:srgbClr val="1B365D"/>
-                </a:solidFill>
-              </a:defRPr>
-            </a:pPr>
-            <a:r>
-              <a:t>2. Validation</a:t>
-            </a:r>
-          </a:p>
-          <a:p>
-            <a:pPr>
-              <a:spcBef>
-                <a:spcPts val="800"/>
-              </a:spcBef>
-              <a:defRPr sz="950">
-                <a:solidFill>
-                  <a:srgbClr val="1A202C"/>
-                </a:solidFill>
-              </a:defRPr>
-            </a:pPr>
-            <a:r>
-              <a:t>Schema &amp; binary target</a:t>
-            </a:r>
-            <a:br/>
-            <a:r>
-              <a:t>verification (100% clean)</a:t>
-            </a:r>
-          </a:p>
-        </p:txBody>
-      </p:sp>
-      <p:sp>
-        <p:nvSpPr>
-          <p:cNvPr id="7" name="Rounded Rectangle 6"/>
-          <p:cNvSpPr/>
-          <p:nvPr/>
-        </p:nvSpPr>
-        <p:spPr>
-          <a:xfrm>
-            <a:off x="3840480" y="2011680"/>
-            <a:ext cx="1417320" cy="2194560"/>
-          </a:xfrm>
-          <a:prstGeom prst="roundRect">
-            <a:avLst/>
-          </a:prstGeom>
-          <a:solidFill>
-            <a:srgbClr val="EBF3FA"/>
-          </a:solidFill>
-          <a:ln>
-            <a:solidFill>
-              <a:srgbClr val="1B365D"/>
-            </a:solidFill>
-          </a:ln>
-        </p:spPr>
-        <p:style>
-          <a:lnRef idx="1">
-            <a:schemeClr val="accent1"/>
-          </a:lnRef>
-          <a:fillRef idx="3">
-            <a:schemeClr val="accent1"/>
-          </a:fillRef>
-          <a:effectRef idx="2">
-            <a:schemeClr val="accent1"/>
-          </a:effectRef>
-          <a:fontRef idx="minor">
-            <a:schemeClr val="lt1"/>
-          </a:fontRef>
-        </p:style>
-        <p:txBody>
-          <a:bodyPr rtlCol="0" anchor="ctr"/>
-          <a:lstStyle/>
-          <a:p>
-            <a:pPr algn="ctr"/>
-          </a:p>
-        </p:txBody>
-      </p:sp>
-      <p:sp>
-        <p:nvSpPr>
-          <p:cNvPr id="8" name="TextBox 7"/>
-          <p:cNvSpPr txBox="1"/>
-          <p:nvPr/>
-        </p:nvSpPr>
-        <p:spPr>
-          <a:xfrm>
-            <a:off x="3886200" y="2148840"/>
-            <a:ext cx="1325880" cy="1920240"/>
-          </a:xfrm>
-          <a:prstGeom prst="rect">
-            <a:avLst/>
-          </a:prstGeom>
-          <a:noFill/>
-        </p:spPr>
-        <p:txBody>
-          <a:bodyPr wrap="square">
-            <a:spAutoFit/>
-          </a:bodyPr>
-          <a:lstStyle/>
-          <a:p>
-            <a:pPr>
-              <a:defRPr sz="1100" b="1">
-                <a:solidFill>
-                  <a:srgbClr val="1B365D"/>
-                </a:solidFill>
-              </a:defRPr>
-            </a:pPr>
-            <a:r>
-              <a:t>3. Storage</a:t>
-            </a:r>
-          </a:p>
-          <a:p>
-            <a:pPr>
-              <a:spcBef>
-                <a:spcPts val="800"/>
-              </a:spcBef>
-              <a:defRPr sz="950">
-                <a:solidFill>
-                  <a:srgbClr val="1A202C"/>
-                </a:solidFill>
-              </a:defRPr>
-            </a:pPr>
-            <a:r>
-              <a:t>Staged JSONL lakehouse</a:t>
-            </a:r>
-            <a:br/>
-            <a:r>
-              <a:t>(Strict split isolation)</a:t>
-            </a:r>
-          </a:p>
-        </p:txBody>
-      </p:sp>
-      <p:sp>
-        <p:nvSpPr>
-          <p:cNvPr id="9" name="Rounded Rectangle 8"/>
-          <p:cNvSpPr/>
-          <p:nvPr/>
-        </p:nvSpPr>
-        <p:spPr>
-          <a:xfrm>
-            <a:off x="5394959" y="2011680"/>
-            <a:ext cx="1417320" cy="2194560"/>
-          </a:xfrm>
-          <a:prstGeom prst="roundRect">
-            <a:avLst/>
-          </a:prstGeom>
-          <a:solidFill>
-            <a:srgbClr val="D1E7DD"/>
-          </a:solidFill>
-          <a:ln>
-            <a:solidFill>
-              <a:srgbClr val="1B365D"/>
-            </a:solidFill>
-          </a:ln>
-        </p:spPr>
-        <p:style>
-          <a:lnRef idx="1">
-            <a:schemeClr val="accent1"/>
-          </a:lnRef>
-          <a:fillRef idx="3">
-            <a:schemeClr val="accent1"/>
-          </a:fillRef>
-          <a:effectRef idx="2">
-            <a:schemeClr val="accent1"/>
-          </a:effectRef>
-          <a:fontRef idx="minor">
-            <a:schemeClr val="lt1"/>
-          </a:fontRef>
-        </p:style>
-        <p:txBody>
-          <a:bodyPr rtlCol="0" anchor="ctr"/>
-          <a:lstStyle/>
-          <a:p>
-            <a:pPr algn="ctr"/>
-          </a:p>
-        </p:txBody>
-      </p:sp>
-      <p:sp>
-        <p:nvSpPr>
-          <p:cNvPr id="10" name="TextBox 9"/>
-          <p:cNvSpPr txBox="1"/>
-          <p:nvPr/>
-        </p:nvSpPr>
-        <p:spPr>
-          <a:xfrm>
-            <a:off x="5440679" y="2148840"/>
-            <a:ext cx="1325880" cy="1920240"/>
-          </a:xfrm>
-          <a:prstGeom prst="rect">
-            <a:avLst/>
-          </a:prstGeom>
-          <a:noFill/>
-        </p:spPr>
-        <p:txBody>
-          <a:bodyPr wrap="square">
-            <a:spAutoFit/>
-          </a:bodyPr>
-          <a:lstStyle/>
-          <a:p>
-            <a:pPr>
-              <a:defRPr sz="1100" b="1">
-                <a:solidFill>
-                  <a:srgbClr val="1B365D"/>
-                </a:solidFill>
-              </a:defRPr>
-            </a:pPr>
-            <a:r>
-              <a:t>4. Transform</a:t>
-            </a:r>
-          </a:p>
-          <a:p>
-            <a:pPr>
-              <a:spcBef>
-                <a:spcPts val="800"/>
-              </a:spcBef>
-              <a:defRPr sz="950">
-                <a:solidFill>
-                  <a:srgbClr val="1A202C"/>
-                </a:solidFill>
-              </a:defRPr>
-            </a:pPr>
-            <a:r>
-              <a:t>DFG variable extraction</a:t>
-            </a:r>
-            <a:br/>
-            <a:r>
-              <a:t>&amp; (K x K) def-use matrix</a:t>
-            </a:r>
-          </a:p>
-        </p:txBody>
-      </p:sp>
-      <p:sp>
-        <p:nvSpPr>
-          <p:cNvPr id="11" name="Rounded Rectangle 10"/>
-          <p:cNvSpPr/>
-          <p:nvPr/>
-        </p:nvSpPr>
-        <p:spPr>
-          <a:xfrm>
-            <a:off x="6949440" y="2011680"/>
-            <a:ext cx="1417320" cy="2194560"/>
-          </a:xfrm>
-          <a:prstGeom prst="roundRect">
-            <a:avLst/>
-          </a:prstGeom>
-          <a:solidFill>
-            <a:srgbClr val="D1E7DD"/>
-          </a:solidFill>
-          <a:ln>
-            <a:solidFill>
-              <a:srgbClr val="1B365D"/>
-            </a:solidFill>
-          </a:ln>
-        </p:spPr>
-        <p:style>
-          <a:lnRef idx="1">
-            <a:schemeClr val="accent1"/>
-          </a:lnRef>
-          <a:fillRef idx="3">
-            <a:schemeClr val="accent1"/>
-          </a:fillRef>
-          <a:effectRef idx="2">
-            <a:schemeClr val="accent1"/>
-          </a:effectRef>
-          <a:fontRef idx="minor">
-            <a:schemeClr val="lt1"/>
-          </a:fontRef>
-        </p:style>
-        <p:txBody>
-          <a:bodyPr rtlCol="0" anchor="ctr"/>
-          <a:lstStyle/>
-          <a:p>
-            <a:pPr algn="ctr"/>
-          </a:p>
-        </p:txBody>
-      </p:sp>
-      <p:sp>
-        <p:nvSpPr>
-          <p:cNvPr id="12" name="TextBox 11"/>
-          <p:cNvSpPr txBox="1"/>
-          <p:nvPr/>
-        </p:nvSpPr>
-        <p:spPr>
-          <a:xfrm>
-            <a:off x="6995160" y="2148840"/>
-            <a:ext cx="1325880" cy="1920240"/>
-          </a:xfrm>
-          <a:prstGeom prst="rect">
-            <a:avLst/>
-          </a:prstGeom>
-          <a:noFill/>
-        </p:spPr>
-        <p:txBody>
-          <a:bodyPr wrap="square">
-            <a:spAutoFit/>
-          </a:bodyPr>
-          <a:lstStyle/>
-          <a:p>
-            <a:pPr>
-              <a:defRPr sz="1100" b="1">
-                <a:solidFill>
-                  <a:srgbClr val="1B365D"/>
-                </a:solidFill>
-              </a:defRPr>
-            </a:pPr>
-            <a:r>
-              <a:t>5. Training</a:t>
-            </a:r>
-          </a:p>
-          <a:p>
-            <a:pPr>
-              <a:spcBef>
-                <a:spcPts val="800"/>
-              </a:spcBef>
-              <a:defRPr sz="950">
-                <a:solidFill>
-                  <a:srgbClr val="1A202C"/>
-                </a:solidFill>
-              </a:defRPr>
-            </a:pPr>
-            <a:r>
-              <a:t>GraphCodeBERT encoder</a:t>
-            </a:r>
-            <a:br/>
-            <a:r>
-              <a:t>+ Graph attention head</a:t>
-            </a:r>
-          </a:p>
-        </p:txBody>
-      </p:sp>
-      <p:sp>
-        <p:nvSpPr>
-          <p:cNvPr id="13" name="Rounded Rectangle 12"/>
-          <p:cNvSpPr/>
-          <p:nvPr/>
-        </p:nvSpPr>
-        <p:spPr>
-          <a:xfrm>
-            <a:off x="8503920" y="2011680"/>
-            <a:ext cx="1417320" cy="2194560"/>
-          </a:xfrm>
-          <a:prstGeom prst="roundRect">
-            <a:avLst/>
-          </a:prstGeom>
-          <a:solidFill>
-            <a:srgbClr val="FFF3CD"/>
-          </a:solidFill>
-          <a:ln>
-            <a:solidFill>
-              <a:srgbClr val="1B365D"/>
-            </a:solidFill>
-          </a:ln>
-        </p:spPr>
-        <p:style>
-          <a:lnRef idx="1">
-            <a:schemeClr val="accent1"/>
-          </a:lnRef>
-          <a:fillRef idx="3">
-            <a:schemeClr val="accent1"/>
-          </a:fillRef>
-          <a:effectRef idx="2">
-            <a:schemeClr val="accent1"/>
-          </a:effectRef>
-          <a:fontRef idx="minor">
-            <a:schemeClr val="lt1"/>
-          </a:fontRef>
-        </p:style>
-        <p:txBody>
-          <a:bodyPr rtlCol="0" anchor="ctr"/>
-          <a:lstStyle/>
-          <a:p>
-            <a:pPr algn="ctr"/>
-          </a:p>
-        </p:txBody>
-      </p:sp>
-      <p:sp>
-        <p:nvSpPr>
-          <p:cNvPr id="14" name="TextBox 13"/>
-          <p:cNvSpPr txBox="1"/>
-          <p:nvPr/>
-        </p:nvSpPr>
-        <p:spPr>
-          <a:xfrm>
-            <a:off x="8549640" y="2148840"/>
-            <a:ext cx="1325880" cy="1920240"/>
-          </a:xfrm>
-          <a:prstGeom prst="rect">
-            <a:avLst/>
-          </a:prstGeom>
-          <a:noFill/>
-        </p:spPr>
-        <p:txBody>
-          <a:bodyPr wrap="square">
-            <a:spAutoFit/>
-          </a:bodyPr>
-          <a:lstStyle/>
-          <a:p>
-            <a:pPr>
-              <a:defRPr sz="1100" b="1">
-                <a:solidFill>
-                  <a:srgbClr val="1B365D"/>
-                </a:solidFill>
-              </a:defRPr>
-            </a:pPr>
-            <a:r>
-              <a:t>6. Evaluation</a:t>
-            </a:r>
-          </a:p>
-          <a:p>
-            <a:pPr>
-              <a:spcBef>
-                <a:spcPts val="800"/>
-              </a:spcBef>
-              <a:defRPr sz="950">
-                <a:solidFill>
-                  <a:srgbClr val="1A202C"/>
-                </a:solidFill>
-              </a:defRPr>
-            </a:pPr>
-            <a:r>
-              <a:t>Accuracy &gt;= 93% target</a:t>
-            </a:r>
-            <a:br/>
-            <a:r>
-              <a:t>(Achieved: 94.44%)</a:t>
-            </a:r>
-          </a:p>
-        </p:txBody>
-      </p:sp>
-      <p:sp>
-        <p:nvSpPr>
-          <p:cNvPr id="15" name="Rounded Rectangle 14"/>
-          <p:cNvSpPr/>
-          <p:nvPr/>
-        </p:nvSpPr>
-        <p:spPr>
-          <a:xfrm>
-            <a:off x="10058400" y="2011680"/>
-            <a:ext cx="1417320" cy="2194560"/>
-          </a:xfrm>
-          <a:prstGeom prst="roundRect">
-            <a:avLst/>
-          </a:prstGeom>
-          <a:solidFill>
-            <a:srgbClr val="F8D7DA"/>
-          </a:solidFill>
-          <a:ln>
-            <a:solidFill>
-              <a:srgbClr val="1B365D"/>
-            </a:solidFill>
-          </a:ln>
-        </p:spPr>
-        <p:style>
-          <a:lnRef idx="1">
-            <a:schemeClr val="accent1"/>
-          </a:lnRef>
-          <a:fillRef idx="3">
-            <a:schemeClr val="accent1"/>
-          </a:fillRef>
-          <a:effectRef idx="2">
-            <a:schemeClr val="accent1"/>
-          </a:effectRef>
-          <a:fontRef idx="minor">
-            <a:schemeClr val="lt1"/>
-          </a:fontRef>
-        </p:style>
-        <p:txBody>
-          <a:bodyPr rtlCol="0" anchor="ctr"/>
-          <a:lstStyle/>
-          <a:p>
-            <a:pPr algn="ctr"/>
-          </a:p>
-        </p:txBody>
-      </p:sp>
-      <p:sp>
-        <p:nvSpPr>
-          <p:cNvPr id="16" name="TextBox 15"/>
-          <p:cNvSpPr txBox="1"/>
-          <p:nvPr/>
-        </p:nvSpPr>
-        <p:spPr>
-          <a:xfrm>
-            <a:off x="10104120" y="2148840"/>
-            <a:ext cx="1325880" cy="1920240"/>
-          </a:xfrm>
-          <a:prstGeom prst="rect">
-            <a:avLst/>
-          </a:prstGeom>
-          <a:noFill/>
-        </p:spPr>
-        <p:txBody>
-          <a:bodyPr wrap="square">
-            <a:spAutoFit/>
-          </a:bodyPr>
-          <a:lstStyle/>
-          <a:p>
-            <a:pPr>
-              <a:defRPr sz="1100" b="1">
-                <a:solidFill>
-                  <a:srgbClr val="1B365D"/>
-                </a:solidFill>
-              </a:defRPr>
-            </a:pPr>
-            <a:r>
-              <a:t>7. Retention</a:t>
-            </a:r>
-          </a:p>
-          <a:p>
-            <a:pPr>
-              <a:spcBef>
-                <a:spcPts val="800"/>
-              </a:spcBef>
-              <a:defRPr sz="950">
-                <a:solidFill>
-                  <a:srgbClr val="1A202C"/>
-                </a:solidFill>
-              </a:defRPr>
-            </a:pPr>
-            <a:r>
-              <a:t>ISO 27001 audit archival</a:t>
-            </a:r>
-            <a:br/>
-            <a:r>
-              <a:t>&amp; credential sanitization</a:t>
-            </a:r>
-          </a:p>
-        </p:txBody>
-      </p:sp>
-      <p:sp>
-        <p:nvSpPr>
-          <p:cNvPr id="17" name="TextBox 16"/>
-          <p:cNvSpPr txBox="1"/>
-          <p:nvPr/>
-        </p:nvSpPr>
-        <p:spPr>
-          <a:xfrm>
-            <a:off x="731520" y="4572000"/>
-            <a:ext cx="10698480" cy="1645920"/>
-          </a:xfrm>
-          <a:prstGeom prst="rect">
-            <a:avLst/>
-          </a:prstGeom>
-          <a:noFill/>
-        </p:spPr>
-        <p:txBody>
-          <a:bodyPr wrap="square">
-            <a:spAutoFit/>
-          </a:bodyPr>
-          <a:lstStyle/>
-          <a:p>
-            <a:pPr>
-              <a:defRPr sz="1300" b="1">
-                <a:solidFill>
-                  <a:srgbClr val="1B365D"/>
-                </a:solidFill>
-              </a:defRPr>
-            </a:pPr>
-            <a:r>
-              <a:t>DAMA-DMBOK2 Mapping:</a:t>
+              <a:t>DAMA-DMBOK2 Mapping &amp; Quality Principles:</a:t>
             </a:r>
           </a:p>
           <a:p>
@@ -5522,7 +4853,7 @@
               </a:defRPr>
             </a:pPr>
             <a:r>
-              <a:t>LECTURE 3 &amp; 4 — DATA FLOW SEMANTICS</a:t>
+              <a:t>LECTURE 3 &amp; 4 — DEEP NEURAL MODELING</a:t>
             </a:r>
           </a:p>
           <a:p>
@@ -5537,21 +4868,45 @@
               </a:defRPr>
             </a:pPr>
             <a:r>
-              <a:t>Data Modeling &amp; Data Flow Graph (DFG) Extraction</a:t>
-            </a:r>
-          </a:p>
-        </p:txBody>
-      </p:sp>
-      <p:sp>
-        <p:nvSpPr>
-          <p:cNvPr id="3" name="TextBox 2"/>
+              <a:t>System Architecture &amp; Data Flow Attention</a:t>
+            </a:r>
+          </a:p>
+        </p:txBody>
+      </p:sp>
+      <p:pic>
+        <p:nvPicPr>
+          <p:cNvPr id="3" name="Picture 2" descr="architecture_diagram.png"/>
+          <p:cNvPicPr>
+            <a:picLocks noChangeAspect="1"/>
+          </p:cNvPicPr>
+          <p:nvPr/>
+        </p:nvPicPr>
+        <p:blipFill>
+          <a:blip r:embed="rId2"/>
+          <a:stretch>
+            <a:fillRect/>
+          </a:stretch>
+        </p:blipFill>
+        <p:spPr>
+          <a:xfrm>
+            <a:off x="731520" y="1371600"/>
+            <a:ext cx="10698480" cy="3931920"/>
+          </a:xfrm>
+          <a:prstGeom prst="rect">
+            <a:avLst/>
+          </a:prstGeom>
+        </p:spPr>
+      </p:pic>
+      <p:sp>
+        <p:nvSpPr>
+          <p:cNvPr id="4" name="TextBox 3"/>
           <p:cNvSpPr txBox="1"/>
           <p:nvPr/>
         </p:nvSpPr>
         <p:spPr>
           <a:xfrm>
-            <a:off x="731520" y="1645920"/>
-            <a:ext cx="10698480" cy="4572000"/>
+            <a:off x="731520" y="5394960"/>
+            <a:ext cx="10698480" cy="1097280"/>
           </a:xfrm>
           <a:prstGeom prst="rect">
             <a:avLst/>
@@ -5563,125 +4918,20 @@
             <a:spAutoFit/>
           </a:bodyPr>
           <a:lstStyle/>
-          <a:p/>
-          <a:p>
-            <a:pPr>
-              <a:spcBef>
-                <a:spcPts val="1000"/>
-              </a:spcBef>
-              <a:defRPr sz="1400" b="1">
-                <a:solidFill>
-                  <a:srgbClr val="1B365D"/>
-                </a:solidFill>
-              </a:defRPr>
-            </a:pPr>
-            <a:r>
-              <a:t>▶  Conceptual Entity Model</a:t>
-            </a:r>
-          </a:p>
-          <a:p>
-            <a:pPr>
-              <a:spcBef>
-                <a:spcPts val="200"/>
-              </a:spcBef>
-              <a:defRPr sz="1150">
+          <a:p>
+            <a:pPr>
+              <a:defRPr sz="1050">
                 <a:solidFill>
                   <a:srgbClr val="1A202C"/>
                 </a:solidFill>
               </a:defRPr>
             </a:pPr>
             <a:r>
-              <a:t>Formalized relational model spanning DATASET_SPLIT, JAVA_FUNCTION, DATA_FLOW_GRAPH, CWE_CATALOG, VULNERABILITY_LABEL, and MODEL_EXPERIMENT.</a:t>
-            </a:r>
-          </a:p>
-          <a:p>
-            <a:pPr>
-              <a:spcBef>
-                <a:spcPts val="1000"/>
-              </a:spcBef>
-              <a:defRPr sz="1400" b="1">
-                <a:solidFill>
-                  <a:srgbClr val="1B365D"/>
-                </a:solidFill>
-              </a:defRPr>
-            </a:pPr>
-            <a:r>
-              <a:t>▶  What is a Data Flow Graph?</a:t>
-            </a:r>
-          </a:p>
-          <a:p>
-            <a:pPr>
-              <a:spcBef>
-                <a:spcPts val="200"/>
-              </a:spcBef>
-              <a:defRPr sz="1150">
-                <a:solidFill>
-                  <a:srgbClr val="1A202C"/>
-                </a:solidFill>
-              </a:defRPr>
-            </a:pPr>
-            <a:r>
-              <a:t>A directed semantic graph where nodes represent variables (e.g. 'userInput', 'query', 'stmt') and edges represent def-use dependencies ('where does the value of this variable originate?').</a:t>
-            </a:r>
-          </a:p>
-          <a:p>
-            <a:pPr>
-              <a:spcBef>
-                <a:spcPts val="1000"/>
-              </a:spcBef>
-              <a:defRPr sz="1400" b="1">
-                <a:solidFill>
-                  <a:srgbClr val="1B365D"/>
-                </a:solidFill>
-              </a:defRPr>
-            </a:pPr>
-            <a:r>
-              <a:t>▶  DFG Extractor Implementation (models/data_flow_extractor.py)</a:t>
-            </a:r>
-          </a:p>
-          <a:p>
-            <a:pPr>
-              <a:spcBef>
-                <a:spcPts val="200"/>
-              </a:spcBef>
-              <a:defRPr sz="1150">
-                <a:solidFill>
-                  <a:srgbClr val="1A202C"/>
-                </a:solidFill>
-              </a:defRPr>
-            </a:pPr>
-            <a:r>
-              <a:t>Lexical scanner extracts candidate variables, tracks assignment definitions (def), conditional/method usages (use), and builds a (K x K) binary adjacency matrix A.</a:t>
-            </a:r>
-          </a:p>
-          <a:p>
-            <a:pPr>
-              <a:spcBef>
-                <a:spcPts val="1000"/>
-              </a:spcBef>
-              <a:defRPr sz="1400" b="1">
-                <a:solidFill>
-                  <a:srgbClr val="1B365D"/>
-                </a:solidFill>
-              </a:defRPr>
-            </a:pPr>
-            <a:r>
-              <a:t>▶  Adjacency-Guided Attention Masking</a:t>
-            </a:r>
-          </a:p>
-          <a:p>
-            <a:pPr>
-              <a:spcBef>
-                <a:spcPts val="200"/>
-              </a:spcBef>
-              <a:defRPr sz="1150">
-                <a:solidFill>
-                  <a:srgbClr val="1A202C"/>
-                </a:solidFill>
-              </a:defRPr>
-            </a:pPr>
-            <a:r>
-              <a:t>Multi-head graph attention restricts attention weights to connected variable pairs in matrix A, allowing the model to focus specifically on semantic data flow trajectories.</a:t>
+              <a:t>• Core Innovation: Graph Attention Pooling dynamically weights candidate variable def-use edges via adjacency matrix A.</a:t>
+            </a:r>
+            <a:br/>
+            <a:r>
+              <a:t>• Tri-Representation Fusion: Concatenates [CLS] sequence embedding, mean token embedding, and pooled DFG node embedding (2304-D) for robust classification.</a:t>
             </a:r>
           </a:p>
         </p:txBody>
@@ -5762,8 +5012,8 @@
         </p:nvSpPr>
         <p:spPr>
           <a:xfrm>
-            <a:off x="731520" y="1645920"/>
-            <a:ext cx="5120640" cy="4572000"/>
+            <a:off x="731520" y="1463040"/>
+            <a:ext cx="5120640" cy="2011680"/>
           </a:xfrm>
           <a:prstGeom prst="rect">
             <a:avLst/>
@@ -5777,103 +5027,71 @@
           <a:lstStyle/>
           <a:p>
             <a:pPr>
-              <a:defRPr sz="1300" b="1">
+              <a:defRPr sz="1200" b="1">
                 <a:solidFill>
                   <a:srgbClr val="C53030"/>
                 </a:solidFill>
               </a:defRPr>
             </a:pPr>
             <a:r>
-              <a:t>Problem 1: Campus Network Port 443 Blocking</a:t>
+              <a:t>Problem 1: Campus Network Port 443 Timeout</a:t>
             </a:r>
           </a:p>
           <a:p>
             <a:pPr>
               <a:spcBef>
-                <a:spcPts val="600"/>
+                <a:spcPts val="400"/>
               </a:spcBef>
-              <a:defRPr sz="1050">
+              <a:defRPr sz="1000">
                 <a:solidFill>
                   <a:srgbClr val="1A202C"/>
                 </a:solidFill>
               </a:defRPr>
             </a:pPr>
             <a:r>
-              <a:t>• Symptom: curl and git push aborted with Error 28 (Connection timed out after 21000ms).</a:t>
-            </a:r>
-          </a:p>
-          <a:p>
-            <a:pPr>
-              <a:spcBef>
-                <a:spcPts val="600"/>
-              </a:spcBef>
-              <a:defRPr sz="1050">
-                <a:solidFill>
-                  <a:srgbClr val="1A202C"/>
-                </a:solidFill>
-              </a:defRPr>
-            </a:pPr>
-            <a:r>
-              <a:t>• Root Cause: Campus Wi-Fi firewall dropped TCP SYN packets to GitHub IP 140.82.121.4.</a:t>
-            </a:r>
-          </a:p>
-          <a:p>
-            <a:pPr>
-              <a:spcBef>
-                <a:spcPts val="600"/>
-              </a:spcBef>
-              <a:defRPr sz="1050">
-                <a:solidFill>
-                  <a:srgbClr val="1A202C"/>
-                </a:solidFill>
-              </a:defRPr>
-            </a:pPr>
-            <a:r>
-              <a:t>• Diagnostic: Discovered Microsoft Azure GitHub Edge (20.205.243.166) was reachable.</a:t>
-            </a:r>
-          </a:p>
-          <a:p>
-            <a:pPr>
-              <a:spcBef>
-                <a:spcPts val="600"/>
-              </a:spcBef>
-              <a:defRPr sz="1050">
-                <a:solidFill>
-                  <a:srgbClr val="1A202C"/>
-                </a:solidFill>
-              </a:defRPr>
-            </a:pPr>
-            <a:r>
-              <a:t>• Resolution: Engineered pipeline/github_proxy.py (local HTTP CONNECT proxy on port 8989).</a:t>
-            </a:r>
-          </a:p>
-          <a:p>
-            <a:pPr>
-              <a:spcBef>
-                <a:spcPts val="600"/>
-              </a:spcBef>
-              <a:defRPr sz="1050">
-                <a:solidFill>
-                  <a:srgbClr val="1A202C"/>
-                </a:solidFill>
-              </a:defRPr>
-            </a:pPr>
-            <a:r>
-              <a:t>• Result: Successfully pushed entire project repository to Tasik1/kbtu-mood-midterm-team2.</a:t>
-            </a:r>
-          </a:p>
-        </p:txBody>
-      </p:sp>
-      <p:sp>
-        <p:nvSpPr>
-          <p:cNvPr id="4" name="TextBox 3"/>
+              <a:t>• Campus Wi-Fi firewall dropped TCP SYN packets to GitHub frontends (140.82.121.4:443).</a:t>
+            </a:r>
+            <a:br/>
+            <a:r>
+              <a:t>• Solution: Engineered local HTTP CONNECT proxy (port 8989) tunneling to reachable Azure edge IP (20.205.243.166).</a:t>
+            </a:r>
+          </a:p>
+        </p:txBody>
+      </p:sp>
+      <p:pic>
+        <p:nvPicPr>
+          <p:cNvPr id="4" name="Picture 3" descr="screenshot_error_git_network.png"/>
+          <p:cNvPicPr>
+            <a:picLocks noChangeAspect="1"/>
+          </p:cNvPicPr>
+          <p:nvPr/>
+        </p:nvPicPr>
+        <p:blipFill>
+          <a:blip r:embed="rId2"/>
+          <a:stretch>
+            <a:fillRect/>
+          </a:stretch>
+        </p:blipFill>
+        <p:spPr>
+          <a:xfrm>
+            <a:off x="731520" y="3566160"/>
+            <a:ext cx="5120640" cy="2834640"/>
+          </a:xfrm>
+          <a:prstGeom prst="rect">
+            <a:avLst/>
+          </a:prstGeom>
+        </p:spPr>
+      </p:pic>
+      <p:sp>
+        <p:nvSpPr>
+          <p:cNvPr id="5" name="TextBox 4"/>
           <p:cNvSpPr txBox="1"/>
           <p:nvPr/>
         </p:nvSpPr>
         <p:spPr>
           <a:xfrm>
-            <a:off x="6217920" y="1645920"/>
-            <a:ext cx="5120640" cy="4572000"/>
+            <a:off x="6217920" y="1463040"/>
+            <a:ext cx="5120640" cy="2011680"/>
           </a:xfrm>
           <a:prstGeom prst="rect">
             <a:avLst/>
@@ -5887,7 +5105,7 @@
           <a:lstStyle/>
           <a:p>
             <a:pPr>
-              <a:defRPr sz="1300" b="1">
+              <a:defRPr sz="1200" b="1">
                 <a:solidFill>
                   <a:srgbClr val="C53030"/>
                 </a:solidFill>
@@ -5900,80 +5118,48 @@
           <a:p>
             <a:pPr>
               <a:spcBef>
-                <a:spcPts val="600"/>
+                <a:spcPts val="400"/>
               </a:spcBef>
-              <a:defRPr sz="1050">
+              <a:defRPr sz="1000">
                 <a:solidFill>
                   <a:srgbClr val="1A202C"/>
                 </a:solidFill>
               </a:defRPr>
             </a:pPr>
             <a:r>
-              <a:t>• Symptom: torch.cuda.OutOfMemoryError: Tried to allocate 512MiB on RTX 3050 (4GB total).</a:t>
-            </a:r>
-          </a:p>
-          <a:p>
-            <a:pPr>
-              <a:spcBef>
-                <a:spcPts val="600"/>
-              </a:spcBef>
-              <a:defRPr sz="1050">
-                <a:solidFill>
-                  <a:srgbClr val="1A202C"/>
-                </a:solidFill>
-              </a:defRPr>
-            </a:pPr>
-            <a:r>
-              <a:t>• Root Cause: Full backpropagation through 12 Transformer layers with L=256 and DFG attention matrices exhausted 4GB VRAM.</a:t>
-            </a:r>
-          </a:p>
-          <a:p>
-            <a:pPr>
-              <a:spcBef>
-                <a:spcPts val="600"/>
-              </a:spcBef>
-              <a:defRPr sz="1050">
-                <a:solidFill>
-                  <a:srgbClr val="1A202C"/>
-                </a:solidFill>
-              </a:defRPr>
-            </a:pPr>
-            <a:r>
-              <a:t>• Diagnostic: Memory profiler identified peak activation memory during backward pass.</a:t>
-            </a:r>
-          </a:p>
-          <a:p>
-            <a:pPr>
-              <a:spcBef>
-                <a:spcPts val="600"/>
-              </a:spcBef>
-              <a:defRPr sz="1050">
-                <a:solidFill>
-                  <a:srgbClr val="1A202C"/>
-                </a:solidFill>
-              </a:defRPr>
-            </a:pPr>
-            <a:r>
-              <a:t>• Resolution: Optimized memory allocation by performing staged GraphCodeBERT feature extraction and training the custom Graph Attention Pooling layer with gradient clipping.</a:t>
-            </a:r>
-          </a:p>
-          <a:p>
-            <a:pPr>
-              <a:spcBef>
-                <a:spcPts val="600"/>
-              </a:spcBef>
-              <a:defRPr sz="1050">
-                <a:solidFill>
-                  <a:srgbClr val="1A202C"/>
-                </a:solidFill>
-              </a:defRPr>
-            </a:pPr>
-            <a:r>
-              <a:t>• Result: Stable training convergence and 94.44% test accuracy achieved.</a:t>
-            </a:r>
-          </a:p>
-        </p:txBody>
-      </p:sp>
+              <a:t>• Simultaneous 12-layer backprop with L=256 and DFG attention tensors exhausted 4GB VRAM on RTX 3050.</a:t>
+            </a:r>
+            <a:br/>
+            <a:r>
+              <a:t>• Solution: Decoupled into staged feature extraction; trained lightweight 4-Head GAT + MLP classifier head.</a:t>
+            </a:r>
+          </a:p>
+        </p:txBody>
+      </p:sp>
+      <p:pic>
+        <p:nvPicPr>
+          <p:cNvPr id="6" name="Picture 5" descr="screenshot_error_cuda_oom.png"/>
+          <p:cNvPicPr>
+            <a:picLocks noChangeAspect="1"/>
+          </p:cNvPicPr>
+          <p:nvPr/>
+        </p:nvPicPr>
+        <p:blipFill>
+          <a:blip r:embed="rId3"/>
+          <a:stretch>
+            <a:fillRect/>
+          </a:stretch>
+        </p:blipFill>
+        <p:spPr>
+          <a:xfrm>
+            <a:off x="6217920" y="3566160"/>
+            <a:ext cx="5120640" cy="2834640"/>
+          </a:xfrm>
+          <a:prstGeom prst="rect">
+            <a:avLst/>
+          </a:prstGeom>
+        </p:spPr>
+      </p:pic>
     </p:spTree>
   </p:cSld>
   <p:clrMapOvr>
@@ -6051,8 +5237,8 @@
           <p:nvPr/>
         </p:nvGraphicFramePr>
         <p:xfrm>
-          <a:off x="731520" y="1645920"/>
-          <a:ext cx="6583680" cy="4389120"/>
+          <a:off x="731520" y="1463040"/>
+          <a:ext cx="5669280" cy="4937760"/>
         </p:xfrm>
         <a:graphic>
           <a:graphicData uri="http://schemas.openxmlformats.org/drawingml/2006/table">
@@ -6061,19 +5247,19 @@
                 <a:tableStyleId>{5C22544A-7EE6-4342-B048-85BDC9FD1C3A}</a:tableStyleId>
               </a:tblPr>
               <a:tblGrid>
-                <a:gridCol w="1645920"/>
-                <a:gridCol w="1645920"/>
-                <a:gridCol w="1645920"/>
-                <a:gridCol w="1645920"/>
+                <a:gridCol w="1417320"/>
+                <a:gridCol w="1417320"/>
+                <a:gridCol w="1417320"/>
+                <a:gridCol w="1417320"/>
               </a:tblGrid>
-              <a:tr h="548640">
+              <a:tr h="617220">
                 <a:tc>
                   <a:txBody>
                     <a:bodyPr/>
                     <a:lstStyle/>
                     <a:p>
                       <a:pPr>
-                        <a:defRPr sz="1000" b="1">
+                        <a:defRPr sz="950" b="1">
                           <a:solidFill>
                             <a:srgbClr val="FFFFFF"/>
                           </a:solidFill>
@@ -6096,14 +5282,14 @@
                     <a:lstStyle/>
                     <a:p>
                       <a:pPr>
-                        <a:defRPr sz="1000" b="1">
+                        <a:defRPr sz="950" b="1">
                           <a:solidFill>
                             <a:srgbClr val="FFFFFF"/>
                           </a:solidFill>
                         </a:defRPr>
                       </a:pPr>
                       <a:r>
-                        <a:t>Target Requirement</a:t>
+                        <a:t>Target</a:t>
                       </a:r>
                     </a:p>
                   </a:txBody>
@@ -6119,7 +5305,7 @@
                     <a:lstStyle/>
                     <a:p>
                       <a:pPr>
-                        <a:defRPr sz="1000" b="1">
+                        <a:defRPr sz="950" b="1">
                           <a:solidFill>
                             <a:srgbClr val="FFFFFF"/>
                           </a:solidFill>
@@ -6142,7 +5328,7 @@
                     <a:lstStyle/>
                     <a:p>
                       <a:pPr>
-                        <a:defRPr sz="1000" b="1">
+                        <a:defRPr sz="950" b="1">
                           <a:solidFill>
                             <a:srgbClr val="FFFFFF"/>
                           </a:solidFill>
@@ -6160,14 +5346,14 @@
                   </a:tcPr>
                 </a:tc>
               </a:tr>
-              <a:tr h="548640">
+              <a:tr h="617220">
                 <a:tc>
                   <a:txBody>
                     <a:bodyPr/>
                     <a:lstStyle/>
                     <a:p>
                       <a:pPr>
-                        <a:defRPr sz="950" b="1"/>
+                        <a:defRPr sz="900" b="1"/>
                       </a:pPr>
                       <a:r>
                         <a:t>Accuracy</a:t>
@@ -6186,7 +5372,7 @@
                     <a:lstStyle/>
                     <a:p>
                       <a:pPr>
-                        <a:defRPr sz="950"/>
+                        <a:defRPr sz="900"/>
                       </a:pPr>
                       <a:r>
                         <a:t>&gt;= 93.0%</a:t>
@@ -6205,7 +5391,7 @@
                     <a:lstStyle/>
                     <a:p>
                       <a:pPr>
-                        <a:defRPr sz="950"/>
+                        <a:defRPr sz="900"/>
                       </a:pPr>
                       <a:r>
                         <a:t>94.44% (238/252)</a:t>
@@ -6224,7 +5410,7 @@
                     <a:lstStyle/>
                     <a:p>
                       <a:pPr>
-                        <a:defRPr sz="950" b="1">
+                        <a:defRPr sz="900" b="1">
                           <a:solidFill>
                             <a:srgbClr val="1B7A43"/>
                           </a:solidFill>
@@ -6242,14 +5428,14 @@
                   </a:tcPr>
                 </a:tc>
               </a:tr>
-              <a:tr h="548640">
+              <a:tr h="617220">
                 <a:tc>
                   <a:txBody>
                     <a:bodyPr/>
                     <a:lstStyle/>
                     <a:p>
                       <a:pPr>
-                        <a:defRPr sz="950" b="1"/>
+                        <a:defRPr sz="900" b="1"/>
                       </a:pPr>
                       <a:r>
                         <a:t>Precision</a:t>
@@ -6268,7 +5454,7 @@
                     <a:lstStyle/>
                     <a:p>
                       <a:pPr>
-                        <a:defRPr sz="950"/>
+                        <a:defRPr sz="900"/>
                       </a:pPr>
                       <a:r>
                         <a:t>Baseline</a:t>
@@ -6287,7 +5473,7 @@
                     <a:lstStyle/>
                     <a:p>
                       <a:pPr>
-                        <a:defRPr sz="950"/>
+                        <a:defRPr sz="900"/>
                       </a:pPr>
                       <a:r>
                         <a:t>95.73%</a:t>
@@ -6306,7 +5492,7 @@
                     <a:lstStyle/>
                     <a:p>
                       <a:pPr>
-                        <a:defRPr sz="950" b="1"/>
+                        <a:defRPr sz="900" b="1"/>
                       </a:pPr>
                       <a:r>
                         <a:t>HIGH CERTAINTY</a:t>
@@ -6320,17 +5506,17 @@
                   </a:tcPr>
                 </a:tc>
               </a:tr>
-              <a:tr h="548640">
+              <a:tr h="617220">
                 <a:tc>
                   <a:txBody>
                     <a:bodyPr/>
                     <a:lstStyle/>
                     <a:p>
                       <a:pPr>
-                        <a:defRPr sz="950" b="1"/>
+                        <a:defRPr sz="900" b="1"/>
                       </a:pPr>
                       <a:r>
-                        <a:t>Recall (Sensitivity)</a:t>
+                        <a:t>Recall (Sens.)</a:t>
                       </a:r>
                     </a:p>
                   </a:txBody>
@@ -6346,7 +5532,7 @@
                     <a:lstStyle/>
                     <a:p>
                       <a:pPr>
-                        <a:defRPr sz="950"/>
+                        <a:defRPr sz="900"/>
                       </a:pPr>
                       <a:r>
                         <a:t>Minimizing FN</a:t>
@@ -6365,7 +5551,7 @@
                     <a:lstStyle/>
                     <a:p>
                       <a:pPr>
-                        <a:defRPr sz="950"/>
+                        <a:defRPr sz="900"/>
                       </a:pPr>
                       <a:r>
                         <a:t>92.68% (114/123)</a:t>
@@ -6384,7 +5570,7 @@
                     <a:lstStyle/>
                     <a:p>
                       <a:pPr>
-                        <a:defRPr sz="950" b="1"/>
+                        <a:defRPr sz="900" b="1"/>
                       </a:pPr>
                       <a:r>
                         <a:t>ROBUST DETECTION</a:t>
@@ -6398,14 +5584,14 @@
                   </a:tcPr>
                 </a:tc>
               </a:tr>
-              <a:tr h="548640">
+              <a:tr h="617220">
                 <a:tc>
                   <a:txBody>
                     <a:bodyPr/>
                     <a:lstStyle/>
                     <a:p>
                       <a:pPr>
-                        <a:defRPr sz="950" b="1"/>
+                        <a:defRPr sz="900" b="1"/>
                       </a:pPr>
                       <a:r>
                         <a:t>Specificity</a:t>
@@ -6424,7 +5610,7 @@
                     <a:lstStyle/>
                     <a:p>
                       <a:pPr>
-                        <a:defRPr sz="950"/>
+                        <a:defRPr sz="900"/>
                       </a:pPr>
                       <a:r>
                         <a:t>Minimizing FP</a:t>
@@ -6443,7 +5629,7 @@
                     <a:lstStyle/>
                     <a:p>
                       <a:pPr>
-                        <a:defRPr sz="950"/>
+                        <a:defRPr sz="900"/>
                       </a:pPr>
                       <a:r>
                         <a:t>96.12% (124/129)</a:t>
@@ -6462,7 +5648,7 @@
                     <a:lstStyle/>
                     <a:p>
                       <a:pPr>
-                        <a:defRPr sz="950" b="1"/>
+                        <a:defRPr sz="900" b="1"/>
                       </a:pPr>
                       <a:r>
                         <a:t>LOW FALSE ALARMS</a:t>
@@ -6476,14 +5662,14 @@
                   </a:tcPr>
                 </a:tc>
               </a:tr>
-              <a:tr h="548640">
+              <a:tr h="617220">
                 <a:tc>
                   <a:txBody>
                     <a:bodyPr/>
                     <a:lstStyle/>
                     <a:p>
                       <a:pPr>
-                        <a:defRPr sz="950" b="1"/>
+                        <a:defRPr sz="900" b="1"/>
                       </a:pPr>
                       <a:r>
                         <a:t>F1-Score</a:t>
@@ -6502,7 +5688,7 @@
                     <a:lstStyle/>
                     <a:p>
                       <a:pPr>
-                        <a:defRPr sz="950"/>
+                        <a:defRPr sz="900"/>
                       </a:pPr>
                       <a:r>
                         <a:t>Harmonic Mean</a:t>
@@ -6521,7 +5707,7 @@
                     <a:lstStyle/>
                     <a:p>
                       <a:pPr>
-                        <a:defRPr sz="950"/>
+                        <a:defRPr sz="900"/>
                       </a:pPr>
                       <a:r>
                         <a:t>94.18%</a:t>
@@ -6540,7 +5726,7 @@
                     <a:lstStyle/>
                     <a:p>
                       <a:pPr>
-                        <a:defRPr sz="950" b="1"/>
+                        <a:defRPr sz="900" b="1"/>
                       </a:pPr>
                       <a:r>
                         <a:t>BALANCED QUALITY</a:t>
@@ -6554,14 +5740,14 @@
                   </a:tcPr>
                 </a:tc>
               </a:tr>
-              <a:tr h="548640">
+              <a:tr h="617220">
                 <a:tc>
                   <a:txBody>
                     <a:bodyPr/>
                     <a:lstStyle/>
                     <a:p>
                       <a:pPr>
-                        <a:defRPr sz="950" b="1"/>
+                        <a:defRPr sz="900" b="1"/>
                       </a:pPr>
                       <a:r>
                         <a:t>ROC-AUC</a:t>
@@ -6580,10 +5766,10 @@
                     <a:lstStyle/>
                     <a:p>
                       <a:pPr>
-                        <a:defRPr sz="950"/>
+                        <a:defRPr sz="900"/>
                       </a:pPr>
                       <a:r>
-                        <a:t>Discriminative Power</a:t>
+                        <a:t>Discrimination</a:t>
                       </a:r>
                     </a:p>
                   </a:txBody>
@@ -6599,7 +5785,7 @@
                     <a:lstStyle/>
                     <a:p>
                       <a:pPr>
-                        <a:defRPr sz="950"/>
+                        <a:defRPr sz="900"/>
                       </a:pPr>
                       <a:r>
                         <a:t>0.9782</a:t>
@@ -6618,7 +5804,7 @@
                     <a:lstStyle/>
                     <a:p>
                       <a:pPr>
-                        <a:defRPr sz="950" b="1"/>
+                        <a:defRPr sz="900" b="1"/>
                       </a:pPr>
                       <a:r>
                         <a:t>OUTSTANDING</a:t>
@@ -6632,14 +5818,14 @@
                   </a:tcPr>
                 </a:tc>
               </a:tr>
-              <a:tr h="548640">
+              <a:tr h="617220">
                 <a:tc>
                   <a:txBody>
                     <a:bodyPr/>
                     <a:lstStyle/>
                     <a:p>
                       <a:pPr>
-                        <a:defRPr sz="950" b="1"/>
+                        <a:defRPr sz="900" b="1"/>
                       </a:pPr>
                       <a:r>
                         <a:t>Confusion Matrix</a:t>
@@ -6658,7 +5844,7 @@
                     <a:lstStyle/>
                     <a:p>
                       <a:pPr>
-                        <a:defRPr sz="950"/>
+                        <a:defRPr sz="900"/>
                       </a:pPr>
                       <a:r>
                         <a:t>N = 252</a:t>
@@ -6677,7 +5863,7 @@
                     <a:lstStyle/>
                     <a:p>
                       <a:pPr>
-                        <a:defRPr sz="950"/>
+                        <a:defRPr sz="900"/>
                       </a:pPr>
                       <a:r>
                         <a:t>TN=124, FP=5, FN=9, TP=114</a:t>
@@ -6696,7 +5882,7 @@
                     <a:lstStyle/>
                     <a:p>
                       <a:pPr>
-                        <a:defRPr sz="950" b="1"/>
+                        <a:defRPr sz="900" b="1"/>
                       </a:pPr>
                       <a:r>
                         <a:t>VERIFIED</a:t>
@@ -6714,16 +5900,64 @@
           </a:graphicData>
         </a:graphic>
       </p:graphicFrame>
-      <p:sp>
-        <p:nvSpPr>
-          <p:cNvPr id="4" name="TextBox 3"/>
+      <p:pic>
+        <p:nvPicPr>
+          <p:cNvPr id="4" name="Picture 3" descr="confusion_matrix.png"/>
+          <p:cNvPicPr>
+            <a:picLocks noChangeAspect="1"/>
+          </p:cNvPicPr>
+          <p:nvPr/>
+        </p:nvPicPr>
+        <p:blipFill>
+          <a:blip r:embed="rId2"/>
+          <a:stretch>
+            <a:fillRect/>
+          </a:stretch>
+        </p:blipFill>
+        <p:spPr>
+          <a:xfrm>
+            <a:off x="6675120" y="1463040"/>
+            <a:ext cx="2468880" cy="2286000"/>
+          </a:xfrm>
+          <a:prstGeom prst="rect">
+            <a:avLst/>
+          </a:prstGeom>
+        </p:spPr>
+      </p:pic>
+      <p:pic>
+        <p:nvPicPr>
+          <p:cNvPr id="5" name="Picture 4" descr="roc_curve.png"/>
+          <p:cNvPicPr>
+            <a:picLocks noChangeAspect="1"/>
+          </p:cNvPicPr>
+          <p:nvPr/>
+        </p:nvPicPr>
+        <p:blipFill>
+          <a:blip r:embed="rId3"/>
+          <a:stretch>
+            <a:fillRect/>
+          </a:stretch>
+        </p:blipFill>
+        <p:spPr>
+          <a:xfrm>
+            <a:off x="9326880" y="1463040"/>
+            <a:ext cx="2468880" cy="2286000"/>
+          </a:xfrm>
+          <a:prstGeom prst="rect">
+            <a:avLst/>
+          </a:prstGeom>
+        </p:spPr>
+      </p:pic>
+      <p:sp>
+        <p:nvSpPr>
+          <p:cNvPr id="6" name="TextBox 5"/>
           <p:cNvSpPr txBox="1"/>
           <p:nvPr/>
         </p:nvSpPr>
         <p:spPr>
           <a:xfrm>
-            <a:off x="7589520" y="1645920"/>
-            <a:ext cx="3840480" cy="4389120"/>
+            <a:off x="6675120" y="3931920"/>
+            <a:ext cx="5120640" cy="2468880"/>
           </a:xfrm>
           <a:prstGeom prst="rect">
             <a:avLst/>
@@ -6737,74 +5971,74 @@
           <a:lstStyle/>
           <a:p>
             <a:pPr>
-              <a:defRPr sz="1400" b="1">
+              <a:defRPr sz="1200" b="1">
                 <a:solidFill>
                   <a:srgbClr val="1B365D"/>
                 </a:solidFill>
               </a:defRPr>
             </a:pPr>
             <a:r>
-              <a:t>Key Analytical Insights:</a:t>
+              <a:t>Key Analytical Findings:</a:t>
             </a:r>
           </a:p>
           <a:p>
             <a:pPr>
               <a:spcBef>
-                <a:spcPts val="800"/>
+                <a:spcPts val="300"/>
               </a:spcBef>
-              <a:defRPr sz="1000">
+              <a:defRPr sz="950">
                 <a:solidFill>
                   <a:srgbClr val="1A202C"/>
                 </a:solidFill>
               </a:defRPr>
             </a:pPr>
             <a:r>
-              <a:t>▶ Threshold Exceeded: GraphCodeBERT + Data Flow Classifier achieves 94.44% Accuracy, comfortably surpassing the syllabus requirement of &gt;= 93%.</a:t>
+              <a:t>• Accuracy (94.44%) comfortably surpasses the course target threshold of &gt;= 93.0%.</a:t>
             </a:r>
           </a:p>
           <a:p>
             <a:pPr>
               <a:spcBef>
-                <a:spcPts val="800"/>
+                <a:spcPts val="300"/>
               </a:spcBef>
-              <a:defRPr sz="1000">
+              <a:defRPr sz="950">
                 <a:solidFill>
                   <a:srgbClr val="1A202C"/>
                 </a:solidFill>
               </a:defRPr>
             </a:pPr>
             <a:r>
-              <a:t>▶ Low False Negatives: Recall reaches 92.68% (only 9 missed vulnerabilities out of 123), critical for production security.</a:t>
+              <a:t>• Recall reaches 92.68% (only 9 missed vulnerabilities out of 123 in test set).</a:t>
             </a:r>
           </a:p>
           <a:p>
             <a:pPr>
               <a:spcBef>
-                <a:spcPts val="800"/>
+                <a:spcPts val="300"/>
               </a:spcBef>
-              <a:defRPr sz="1000">
+              <a:defRPr sz="950">
                 <a:solidFill>
                   <a:srgbClr val="1A202C"/>
                 </a:solidFill>
               </a:defRPr>
             </a:pPr>
             <a:r>
-              <a:t>▶ High Specificity: Specificity of 96.12% (only 5 false positives) eliminates alert fatigue for software developers.</a:t>
+              <a:t>• Specificity of 96.12% (only 5 false alarms) prevents developer alert fatigue.</a:t>
             </a:r>
           </a:p>
           <a:p>
             <a:pPr>
               <a:spcBef>
-                <a:spcPts val="800"/>
+                <a:spcPts val="300"/>
               </a:spcBef>
-              <a:defRPr sz="1000">
+              <a:defRPr sz="950">
                 <a:solidFill>
                   <a:srgbClr val="1A202C"/>
                 </a:solidFill>
               </a:defRPr>
             </a:pPr>
             <a:r>
-              <a:t>▶ ROC-AUC Calibration: ROC-AUC of 0.9782 confirms exceptional probability calibration across diverse CWE vulnerability categories.</a:t>
+              <a:t>• ROC-AUC of 0.9782 demonstrates outstanding discriminatory power across CWEs.</a:t>
             </a:r>
           </a:p>
         </p:txBody>

</xml_diff>